<commit_message>
docs: restructure VoNR specs into spec-doc sets and merge current/plan into overview
- docs/overview: merge docs/current + docs/plan; rewrite current-state and plan
  (G0–G4 gates per sub-stage, CHK-based acceptance, 12-week schedule),
  add 3GPP conformance review and W2/W7 checklists
- docs/rx-n5: W3a–W3d + W4 Kamailio side, with ADRs and test plan
- docs/smf-n1n2: W5a–W5d + W6 free-ran-ue patch
- docs/hss-udm: W8 HSS-in-UDM (plan B)
- docs/e2e-harness: W1 E2E capture/check harness
- slides and background docs updated to match

Co-Authored-By: Claude Opus 5.5 (1M context) <noreply@anthropic.com>
</commit_message>
<xml_diff>
--- a/slides/VoNR_over_IMS_kamailio_intro.pptx
+++ b/slides/VoNR_over_IMS_kamailio_intro.pptx
@@ -15,14 +15,14 @@
     <p:sldId id="263" r:id="rId9"/>
     <p:sldId id="264" r:id="rId10"/>
     <p:sldId id="265" r:id="rId11"/>
-    <p:sldId id="266" r:id="rId12"/>
+    <p:sldId id="284" r:id="rId30"/>
     <p:sldId id="267" r:id="rId13"/>
     <p:sldId id="268" r:id="rId14"/>
     <p:sldId id="269" r:id="rId15"/>
     <p:sldId id="270" r:id="rId16"/>
     <p:sldId id="271" r:id="rId17"/>
     <p:sldId id="272" r:id="rId18"/>
-    <p:sldId id="273" r:id="rId19"/>
+    <p:sldId id="285" r:id="rId31"/>
     <p:sldId id="274" r:id="rId20"/>
     <p:sldId id="275" r:id="rId21"/>
     <p:sldId id="276" r:id="rId22"/>
@@ -1935,524 +1935,6 @@
 </p:sld>
 </file>
 
-<file path=ppt/slides/slide11.xml><?xml version="1.0" encoding="utf-8"?>
-<p:sld xmlns:a="http://schemas.openxmlformats.org/drawingml/2006/main" xmlns:r="http://schemas.openxmlformats.org/officeDocument/2006/relationships" xmlns:p="http://schemas.openxmlformats.org/presentationml/2006/main">
-  <p:cSld>
-    <p:bg>
-      <p:bgPr>
-        <a:solidFill>
-          <a:srgbClr val="F6F7F9"/>
-        </a:solidFill>
-        <a:effectLst/>
-      </p:bgPr>
-    </p:bg>
-    <p:spTree>
-      <p:nvGrpSpPr>
-        <p:cNvPr id="1" name=""/>
-        <p:cNvGrpSpPr/>
-        <p:nvPr/>
-      </p:nvGrpSpPr>
-      <p:grpSpPr>
-        <a:xfrm>
-          <a:off x="0" y="0"/>
-          <a:ext cx="0" cy="0"/>
-          <a:chOff x="0" y="0"/>
-          <a:chExt cx="0" cy="0"/>
-        </a:xfrm>
-      </p:grpSpPr>
-      <p:sp>
-        <p:nvSpPr>
-          <p:cNvPr id="3" name="Shape 3">
-            <a:extLst>
-              <a:ext uri="{FF2B5EF4-FFF2-40B4-BE49-F238E27FC236}">
-                <a16:creationId xmlns:a16="http://schemas.microsoft.com/office/drawing/2014/main" id="{59ED8FD9-AACB-4234-8DE7-27945DAF8F40}"/>
-              </a:ext>
-            </a:extLst>
-          </p:cNvPr>
-          <p:cNvSpPr/>
-          <p:nvPr/>
-        </p:nvSpPr>
-        <p:spPr>
-          <a:xfrm>
-            <a:off x="0" y="0"/>
-            <a:ext cx="4000500" cy="6858000"/>
-          </a:xfrm>
-          <a:prstGeom prst="rect">
-            <a:avLst/>
-          </a:prstGeom>
-          <a:solidFill>
-            <a:srgbClr val="0F4C81"/>
-          </a:solidFill>
-        </p:spPr>
-        <p:txBody>
-          <a:bodyPr wrap="square" rtlCol="0"/>
-          <a:lstStyle/>
-          <a:p>
-            <a:r>
-              <a:rPr/>
-              <a:t/>
-            </a:r>
-          </a:p>
-        </p:txBody>
-      </p:sp>
-      <p:sp>
-        <p:nvSpPr>
-          <p:cNvPr id="4" name="TextBox 4">
-            <a:extLst>
-              <a:ext uri="{FF2B5EF4-FFF2-40B4-BE49-F238E27FC236}">
-                <a16:creationId xmlns:a16="http://schemas.microsoft.com/office/drawing/2014/main" id="{79CDDD20-114A-4299-843B-43D6F19B28B6}"/>
-              </a:ext>
-            </a:extLst>
-          </p:cNvPr>
-          <p:cNvSpPr txBox="1"/>
-          <p:nvPr/>
-        </p:nvSpPr>
-        <p:spPr>
-          <a:xfrm>
-            <a:off x="571500" y="1428750"/>
-            <a:ext cx="3048000" cy="2857500"/>
-          </a:xfrm>
-        </p:spPr>
-        <p:txBody>
-          <a:bodyPr wrap="square" rtlCol="0" lIns="0" tIns="0" rIns="0" bIns="0" anchor="t">
-            <a:spAutoFit/>
-          </a:bodyPr>
-          <a:lstStyle/>
-          <a:p>
-            <a:r>
-              <a:rPr sz="16000" b="1">
-                <a:solidFill>
-                  <a:srgbClr val="FFFFFF"/>
-                </a:solidFill>
-              </a:rPr>
-              <a:t>3</a:t>
-            </a:r>
-          </a:p>
-        </p:txBody>
-      </p:sp>
-      <p:sp>
-        <p:nvSpPr>
-          <p:cNvPr id="5" name="TextBox 5">
-            <a:extLst>
-              <a:ext uri="{FF2B5EF4-FFF2-40B4-BE49-F238E27FC236}">
-                <a16:creationId xmlns:a16="http://schemas.microsoft.com/office/drawing/2014/main" id="{FDFAEC11-D857-444E-8727-CB9457029E82}"/>
-              </a:ext>
-            </a:extLst>
-          </p:cNvPr>
-          <p:cNvSpPr txBox="1"/>
-          <p:nvPr/>
-        </p:nvSpPr>
-        <p:spPr>
-          <a:xfrm>
-            <a:off x="571500" y="4381500"/>
-            <a:ext cx="3048000" cy="1238250"/>
-          </a:xfrm>
-        </p:spPr>
-        <p:txBody>
-          <a:bodyPr wrap="square" rtlCol="0" lIns="0" tIns="0" rIns="0" bIns="0" anchor="t">
-            <a:spAutoFit/>
-          </a:bodyPr>
-          <a:lstStyle/>
-          <a:p>
-            <a:pPr>
-              <a:spcAft>
-                <a:spcPts val="800"/>
-              </a:spcAft>
-            </a:pPr>
-            <a:r>
-              <a:rPr sz="2200" b="1">
-                <a:solidFill>
-                  <a:srgbClr val="FFFFFF"/>
-                </a:solidFill>
-              </a:rPr>
-              <a:t>5GC 與 IMS 只有 3 個接點</a:t>
-            </a:r>
-          </a:p>
-        </p:txBody>
-      </p:sp>
-      <p:sp>
-        <p:nvSpPr>
-          <p:cNvPr id="6" name="Shape 6">
-            <a:extLst>
-              <a:ext uri="{FF2B5EF4-FFF2-40B4-BE49-F238E27FC236}">
-                <a16:creationId xmlns:a16="http://schemas.microsoft.com/office/drawing/2014/main" id="{AA04B282-932B-4ADF-83F9-CDEA2A6200DD}"/>
-              </a:ext>
-            </a:extLst>
-          </p:cNvPr>
-          <p:cNvSpPr/>
-          <p:nvPr/>
-        </p:nvSpPr>
-        <p:spPr>
-          <a:xfrm>
-            <a:off x="4572000" y="762000"/>
-            <a:ext cx="1143000" cy="533400"/>
-          </a:xfrm>
-          <a:prstGeom prst="roundRect">
-            <a:avLst/>
-          </a:prstGeom>
-          <a:solidFill>
-            <a:srgbClr val="E8742A"/>
-          </a:solidFill>
-        </p:spPr>
-        <p:txBody>
-          <a:bodyPr wrap="square" rtlCol="0" lIns="0" tIns="0" rIns="0" bIns="0" anchor="ctr"/>
-          <a:lstStyle/>
-          <a:p>
-            <a:pPr algn="ctr"/>
-            <a:r>
-              <a:rPr sz="2200" b="1">
-                <a:solidFill>
-                  <a:srgbClr val="FFFFFF"/>
-                </a:solidFill>
-              </a:rPr>
-              <a:t>N6</a:t>
-            </a:r>
-          </a:p>
-        </p:txBody>
-      </p:sp>
-      <p:sp>
-        <p:nvSpPr>
-          <p:cNvPr id="7" name="TextBox 7">
-            <a:extLst>
-              <a:ext uri="{FF2B5EF4-FFF2-40B4-BE49-F238E27FC236}">
-                <a16:creationId xmlns:a16="http://schemas.microsoft.com/office/drawing/2014/main" id="{D085E637-8E34-445D-9EE1-C76DCDF4E2D9}"/>
-              </a:ext>
-            </a:extLst>
-          </p:cNvPr>
-          <p:cNvSpPr txBox="1"/>
-          <p:nvPr/>
-        </p:nvSpPr>
-        <p:spPr>
-          <a:xfrm>
-            <a:off x="6000750" y="762000"/>
-            <a:ext cx="5524500" cy="1238250"/>
-          </a:xfrm>
-        </p:spPr>
-        <p:txBody>
-          <a:bodyPr wrap="square" rtlCol="0" lIns="0" tIns="0" rIns="0" bIns="0" anchor="t">
-            <a:spAutoFit/>
-          </a:bodyPr>
-          <a:lstStyle/>
-          <a:p>
-            <a:pPr>
-              <a:spcAft>
-                <a:spcPts val="600"/>
-              </a:spcAft>
-            </a:pPr>
-            <a:r>
-              <a:rPr sz="1800" b="1">
-                <a:solidFill>
-                  <a:srgbClr val="14213D"/>
-                </a:solidFill>
-              </a:rPr>
-              <a:t>資料面：SIP 與 RTP 都走 PDU session</a:t>
-            </a:r>
-          </a:p>
-          <a:p>
-            <a:r>
-              <a:rPr sz="1400">
-                <a:solidFill>
-                  <a:srgbClr val="5B6575"/>
-                </a:solidFill>
-              </a:rPr>
-              <a:t>ims DNN 經 UPF 到 P-CSCF；不做 NAT，PCF 靠 UE IP 綁定 session</a:t>
-            </a:r>
-          </a:p>
-        </p:txBody>
-      </p:sp>
-      <p:sp>
-        <p:nvSpPr>
-          <p:cNvPr id="8" name="Shape 8">
-            <a:extLst>
-              <a:ext uri="{FF2B5EF4-FFF2-40B4-BE49-F238E27FC236}">
-                <a16:creationId xmlns:a16="http://schemas.microsoft.com/office/drawing/2014/main" id="{D1D58ACC-1201-4DCE-8DB2-B3C9DAF04B53}"/>
-              </a:ext>
-            </a:extLst>
-          </p:cNvPr>
-          <p:cNvSpPr/>
-          <p:nvPr/>
-        </p:nvSpPr>
-        <p:spPr>
-          <a:xfrm>
-            <a:off x="4572000" y="2247900"/>
-            <a:ext cx="6953250" cy="9525"/>
-          </a:xfrm>
-          <a:prstGeom prst="rect">
-            <a:avLst/>
-          </a:prstGeom>
-          <a:solidFill>
-            <a:srgbClr val="D5DAE1"/>
-          </a:solidFill>
-        </p:spPr>
-        <p:txBody>
-          <a:bodyPr wrap="square" rtlCol="0"/>
-          <a:lstStyle/>
-          <a:p>
-            <a:r>
-              <a:rPr/>
-              <a:t/>
-            </a:r>
-          </a:p>
-        </p:txBody>
-      </p:sp>
-      <p:sp>
-        <p:nvSpPr>
-          <p:cNvPr id="9" name="Shape 9">
-            <a:extLst>
-              <a:ext uri="{FF2B5EF4-FFF2-40B4-BE49-F238E27FC236}">
-                <a16:creationId xmlns:a16="http://schemas.microsoft.com/office/drawing/2014/main" id="{968F2E6F-8D64-4D95-AA8B-05D191EDDFE3}"/>
-              </a:ext>
-            </a:extLst>
-          </p:cNvPr>
-          <p:cNvSpPr/>
-          <p:nvPr/>
-        </p:nvSpPr>
-        <p:spPr>
-          <a:xfrm>
-            <a:off x="4572000" y="2571750"/>
-            <a:ext cx="1143000" cy="533400"/>
-          </a:xfrm>
-          <a:prstGeom prst="roundRect">
-            <a:avLst/>
-          </a:prstGeom>
-          <a:solidFill>
-            <a:srgbClr val="E8742A"/>
-          </a:solidFill>
-        </p:spPr>
-        <p:txBody>
-          <a:bodyPr wrap="square" rtlCol="0" lIns="0" tIns="0" rIns="0" bIns="0" anchor="ctr"/>
-          <a:lstStyle/>
-          <a:p>
-            <a:pPr algn="ctr"/>
-            <a:r>
-              <a:rPr sz="2200" b="1">
-                <a:solidFill>
-                  <a:srgbClr val="FFFFFF"/>
-                </a:solidFill>
-              </a:rPr>
-              <a:t>PCO</a:t>
-            </a:r>
-          </a:p>
-        </p:txBody>
-      </p:sp>
-      <p:sp>
-        <p:nvSpPr>
-          <p:cNvPr id="10" name="TextBox 10">
-            <a:extLst>
-              <a:ext uri="{FF2B5EF4-FFF2-40B4-BE49-F238E27FC236}">
-                <a16:creationId xmlns:a16="http://schemas.microsoft.com/office/drawing/2014/main" id="{79E56D0E-4788-4AA5-809F-6E5B41C967A2}"/>
-              </a:ext>
-            </a:extLst>
-          </p:cNvPr>
-          <p:cNvSpPr txBox="1"/>
-          <p:nvPr/>
-        </p:nvSpPr>
-        <p:spPr>
-          <a:xfrm>
-            <a:off x="6000750" y="2571750"/>
-            <a:ext cx="5524500" cy="1238250"/>
-          </a:xfrm>
-        </p:spPr>
-        <p:txBody>
-          <a:bodyPr wrap="square" rtlCol="0" lIns="0" tIns="0" rIns="0" bIns="0" anchor="t">
-            <a:spAutoFit/>
-          </a:bodyPr>
-          <a:lstStyle/>
-          <a:p>
-            <a:pPr>
-              <a:spcAft>
-                <a:spcPts val="600"/>
-              </a:spcAft>
-            </a:pPr>
-            <a:r>
-              <a:rPr sz="1800" b="1">
-                <a:solidFill>
-                  <a:srgbClr val="14213D"/>
-                </a:solidFill>
-              </a:rPr>
-              <a:t>探索：SMF 告訴 UE 「P-CSCF 在哪」</a:t>
-            </a:r>
-          </a:p>
-          <a:p>
-            <a:r>
-              <a:rPr sz="1400">
-                <a:solidFill>
-                  <a:srgbClr val="5B6575"/>
-                </a:solidFill>
-              </a:rPr>
-              <a:t>UE 建 PDU session 時要求，SMF 在 Accept 回傳</a:t>
-            </a:r>
-          </a:p>
-        </p:txBody>
-      </p:sp>
-      <p:sp>
-        <p:nvSpPr>
-          <p:cNvPr id="11" name="Shape 11">
-            <a:extLst>
-              <a:ext uri="{FF2B5EF4-FFF2-40B4-BE49-F238E27FC236}">
-                <a16:creationId xmlns:a16="http://schemas.microsoft.com/office/drawing/2014/main" id="{455D33F7-C127-4524-A2F9-AA344D960A79}"/>
-              </a:ext>
-            </a:extLst>
-          </p:cNvPr>
-          <p:cNvSpPr/>
-          <p:nvPr/>
-        </p:nvSpPr>
-        <p:spPr>
-          <a:xfrm>
-            <a:off x="4572000" y="4057650"/>
-            <a:ext cx="6953250" cy="9525"/>
-          </a:xfrm>
-          <a:prstGeom prst="rect">
-            <a:avLst/>
-          </a:prstGeom>
-          <a:solidFill>
-            <a:srgbClr val="D5DAE1"/>
-          </a:solidFill>
-        </p:spPr>
-        <p:txBody>
-          <a:bodyPr wrap="square" rtlCol="0"/>
-          <a:lstStyle/>
-          <a:p>
-            <a:r>
-              <a:rPr/>
-              <a:t/>
-            </a:r>
-          </a:p>
-        </p:txBody>
-      </p:sp>
-      <p:sp>
-        <p:nvSpPr>
-          <p:cNvPr id="12" name="Shape 12">
-            <a:extLst>
-              <a:ext uri="{FF2B5EF4-FFF2-40B4-BE49-F238E27FC236}">
-                <a16:creationId xmlns:a16="http://schemas.microsoft.com/office/drawing/2014/main" id="{BD256CBB-4F6C-4AF3-9B72-82AD06D0962A}"/>
-              </a:ext>
-            </a:extLst>
-          </p:cNvPr>
-          <p:cNvSpPr/>
-          <p:nvPr/>
-        </p:nvSpPr>
-        <p:spPr>
-          <a:xfrm>
-            <a:off x="4572000" y="4381500"/>
-            <a:ext cx="1143000" cy="533400"/>
-          </a:xfrm>
-          <a:prstGeom prst="roundRect">
-            <a:avLst/>
-          </a:prstGeom>
-          <a:solidFill>
-            <a:srgbClr val="E8742A"/>
-          </a:solidFill>
-        </p:spPr>
-        <p:txBody>
-          <a:bodyPr wrap="square" rtlCol="0" lIns="0" tIns="0" rIns="0" bIns="0" anchor="ctr"/>
-          <a:lstStyle/>
-          <a:p>
-            <a:pPr algn="ctr"/>
-            <a:r>
-              <a:rPr sz="2200" b="1">
-                <a:solidFill>
-                  <a:srgbClr val="FFFFFF"/>
-                </a:solidFill>
-              </a:rPr>
-              <a:t>N5</a:t>
-            </a:r>
-          </a:p>
-        </p:txBody>
-      </p:sp>
-      <p:sp>
-        <p:nvSpPr>
-          <p:cNvPr id="13" name="TextBox 13">
-            <a:extLst>
-              <a:ext uri="{FF2B5EF4-FFF2-40B4-BE49-F238E27FC236}">
-                <a16:creationId xmlns:a16="http://schemas.microsoft.com/office/drawing/2014/main" id="{5D384B93-227C-4475-8B78-4D26B62BA806}"/>
-              </a:ext>
-            </a:extLst>
-          </p:cNvPr>
-          <p:cNvSpPr txBox="1"/>
-          <p:nvPr/>
-        </p:nvSpPr>
-        <p:spPr>
-          <a:xfrm>
-            <a:off x="6000750" y="4381500"/>
-            <a:ext cx="5524500" cy="1238250"/>
-          </a:xfrm>
-        </p:spPr>
-        <p:txBody>
-          <a:bodyPr wrap="square" rtlCol="0" lIns="0" tIns="0" rIns="0" bIns="0" anchor="t">
-            <a:spAutoFit/>
-          </a:bodyPr>
-          <a:lstStyle/>
-          <a:p>
-            <a:pPr>
-              <a:spcAft>
-                <a:spcPts val="600"/>
-              </a:spcAft>
-            </a:pPr>
-            <a:r>
-              <a:rPr sz="1800" b="1">
-                <a:solidFill>
-                  <a:srgbClr val="14213D"/>
-                </a:solidFill>
-              </a:rPr>
-              <a:t>控制面：P-CSCF 以 AF 身分向 PCF 要 QoS</a:t>
-            </a:r>
-          </a:p>
-          <a:p>
-            <a:r>
-              <a:rPr sz="1400">
-                <a:solidFill>
-                  <a:srgbClr val="5B6575"/>
-                </a:solidFill>
-              </a:rPr>
-              <a:t>語音 flow 從 5QI 5 升到 5QI 1（GBR）</a:t>
-            </a:r>
-          </a:p>
-        </p:txBody>
-      </p:sp>
-      <p:sp>
-        <p:nvSpPr>
-          <p:cNvPr id="14" name="TextBox 14">
-            <a:extLst>
-              <a:ext uri="{FF2B5EF4-FFF2-40B4-BE49-F238E27FC236}">
-                <a16:creationId xmlns:a16="http://schemas.microsoft.com/office/drawing/2014/main" id="{B37C70F8-7760-46D2-AD28-D0DD715189CB}"/>
-              </a:ext>
-            </a:extLst>
-          </p:cNvPr>
-          <p:cNvSpPr txBox="1"/>
-          <p:nvPr/>
-        </p:nvSpPr>
-        <p:spPr>
-          <a:xfrm>
-            <a:off x="4572000" y="6000750"/>
-            <a:ext cx="6953250" cy="381000"/>
-          </a:xfrm>
-        </p:spPr>
-        <p:txBody>
-          <a:bodyPr wrap="square" rtlCol="0" lIns="0" tIns="0" rIns="0" bIns="0" anchor="t">
-            <a:spAutoFit/>
-          </a:bodyPr>
-          <a:lstStyle/>
-          <a:p>
-            <a:r>
-              <a:rPr sz="1300">
-                <a:solidFill>
-                  <a:srgbClr val="5B6575"/>
-                </a:solidFill>
-              </a:rPr>
-              <a:t>其餘各自獨立：UDR 與 HSS 無介面，各自認證</a:t>
-            </a:r>
-          </a:p>
-        </p:txBody>
-      </p:sp>
-    </p:spTree>
-  </p:cSld>
-  <p:clrMapOvr>
-    <a:masterClrMapping/>
-  </p:clrMapOvr>
-</p:sld>
-</file>
-
 <file path=ppt/slides/slide12.xml><?xml version="1.0" encoding="utf-8"?>
 <p:sld xmlns:a="http://schemas.openxmlformats.org/drawingml/2006/main" xmlns:r="http://schemas.openxmlformats.org/officeDocument/2006/relationships" xmlns:p="http://schemas.openxmlformats.org/presentationml/2006/main">
   <p:cSld name="free5GC 接 IMS：資料路徑與政策控制">
@@ -4500,7 +3982,7 @@
                 <a:ea typeface="Noto Sans CJK TC"/>
                 <a:cs typeface="Noto Sans CJK TC"/>
               </a:rPr>
-              <a:t>IMS-to-5GC AF Adapter</a:t>
+              <a:t>AF shim（現況）</a:t>
             </a:r>
             <a:endParaRPr lang="zh-TW" sz="1575"/>
           </a:p>
@@ -4700,14 +4182,14 @@
       </p:sp>
       <p:sp>
         <p:nvSpPr>
-          <p:cNvPr id="65" name="n7-name"/>
-          <p:cNvSpPr txBox="1"/>
-          <p:nvPr/>
-        </p:nvSpPr>
-        <p:spPr>
-          <a:xfrm>
-            <a:off x="3943350" y="2838450"/>
-            <a:ext cx="1819275" cy="219075"/>
+          <p:cNvPr id="64" name="n5-transport"/>
+          <p:cNvSpPr txBox="1"/>
+          <p:nvPr/>
+        </p:nvSpPr>
+        <p:spPr>
+          <a:xfrm>
+            <a:off x="4505325" y="2533650"/>
+            <a:ext cx="2152650" cy="238125"/>
           </a:xfrm>
           <a:prstGeom prst="rect">
             <a:avLst/>
@@ -4723,6 +4205,54 @@
           </a:bodyPr>
           <a:lstStyle/>
           <a:p>
+            <a:pPr algn="ctr">
+              <a:lnSpc>
+                <a:spcPct val="112000"/>
+              </a:lnSpc>
+              <a:spcAft>
+                <a:spcPts val="0"/>
+              </a:spcAft>
+            </a:pPr>
+            <a:r>
+              <a:rPr lang="zh-TW" sz="1125" b="0">
+                <a:solidFill>
+                  <a:srgbClr val="5B6575"/>
+                </a:solidFill>
+                <a:latin typeface="Noto Sans CJK TC"/>
+                <a:ea typeface="Noto Sans CJK TC"/>
+                <a:cs typeface="Noto Sans CJK TC"/>
+              </a:rPr>
+              <a:t>HTTP/2 SBI (h2c)</a:t>
+            </a:r>
+            <a:endParaRPr lang="zh-TW" sz="1125"/>
+          </a:p>
+        </p:txBody>
+      </p:sp>
+      <p:sp>
+        <p:nvSpPr>
+          <p:cNvPr id="65" name="n7-name"/>
+          <p:cNvSpPr txBox="1"/>
+          <p:nvPr/>
+        </p:nvSpPr>
+        <p:spPr>
+          <a:xfrm>
+            <a:off x="3943350" y="2838450"/>
+            <a:ext cx="1819275" cy="219075"/>
+          </a:xfrm>
+          <a:prstGeom prst="rect">
+            <a:avLst/>
+          </a:prstGeom>
+          <a:noFill/>
+          <a:ln>
+            <a:noFill/>
+          </a:ln>
+        </p:spPr>
+        <p:txBody>
+          <a:bodyPr wrap="none" lIns="0" rIns="0" tIns="0" bIns="0" anchor="t">
+            <a:noAutofit/>
+          </a:bodyPr>
+          <a:lstStyle/>
+          <a:p>
             <a:pPr algn="l">
               <a:lnSpc>
                 <a:spcPct val="112000"/>
@@ -4748,14 +4278,14 @@
       </p:sp>
       <p:sp>
         <p:nvSpPr>
-          <p:cNvPr id="67" name="n7-transport"/>
-          <p:cNvSpPr txBox="1"/>
-          <p:nvPr/>
-        </p:nvSpPr>
-        <p:spPr>
-          <a:xfrm>
-            <a:off x="4610100" y="3314700"/>
-            <a:ext cx="1190625" cy="219075"/>
+          <p:cNvPr id="66" name="n7-semantic"/>
+          <p:cNvSpPr txBox="1"/>
+          <p:nvPr/>
+        </p:nvSpPr>
+        <p:spPr>
+          <a:xfrm>
+            <a:off x="3943350" y="3067050"/>
+            <a:ext cx="1857375" cy="219075"/>
           </a:xfrm>
           <a:prstGeom prst="rect">
             <a:avLst/>
@@ -4780,7 +4310,7 @@
               </a:spcAft>
             </a:pPr>
             <a:r>
-              <a:rPr lang="zh-TW" sz="1050" b="0">
+              <a:rPr lang="zh-TW" sz="1125" b="0">
                 <a:solidFill>
                   <a:srgbClr val="5B6575"/>
                 </a:solidFill>
@@ -4788,22 +4318,22 @@
                 <a:ea typeface="Noto Sans CJK TC"/>
                 <a:cs typeface="Noto Sans CJK TC"/>
               </a:rPr>
-              <a:t>HTTP/2 SBI</a:t>
-            </a:r>
-            <a:endParaRPr lang="zh-TW" sz="1050"/>
-          </a:p>
-        </p:txBody>
-      </p:sp>
-      <p:sp>
-        <p:nvSpPr>
-          <p:cNvPr id="68" name="n4-name"/>
-          <p:cNvSpPr txBox="1"/>
-          <p:nvPr/>
-        </p:nvSpPr>
-        <p:spPr>
-          <a:xfrm>
-            <a:off x="3943350" y="4105275"/>
-            <a:ext cx="1476375" cy="228600"/>
+              <a:t>Npcf_SMPolicyControl</a:t>
+            </a:r>
+            <a:endParaRPr lang="zh-TW" sz="1125"/>
+          </a:p>
+        </p:txBody>
+      </p:sp>
+      <p:sp>
+        <p:nvSpPr>
+          <p:cNvPr id="67" name="n7-transport"/>
+          <p:cNvSpPr txBox="1"/>
+          <p:nvPr/>
+        </p:nvSpPr>
+        <p:spPr>
+          <a:xfrm>
+            <a:off x="4610100" y="3314700"/>
+            <a:ext cx="1190625" cy="219075"/>
           </a:xfrm>
           <a:prstGeom prst="rect">
             <a:avLst/>
@@ -4828,30 +4358,30 @@
               </a:spcAft>
             </a:pPr>
             <a:r>
-              <a:rPr lang="zh-TW" sz="1350" b="1">
-                <a:solidFill>
-                  <a:srgbClr val="14213D"/>
+              <a:rPr lang="zh-TW" sz="1050" b="0">
+                <a:solidFill>
+                  <a:srgbClr val="5B6575"/>
                 </a:solidFill>
                 <a:latin typeface="Noto Sans CJK TC"/>
                 <a:ea typeface="Noto Sans CJK TC"/>
                 <a:cs typeface="Noto Sans CJK TC"/>
               </a:rPr>
-              <a:t>N4</a:t>
-            </a:r>
-            <a:endParaRPr lang="zh-TW" sz="1350"/>
-          </a:p>
-        </p:txBody>
-      </p:sp>
-      <p:sp>
-        <p:nvSpPr>
-          <p:cNvPr id="69" name="n4-protocol"/>
-          <p:cNvSpPr txBox="1"/>
-          <p:nvPr/>
-        </p:nvSpPr>
-        <p:spPr>
-          <a:xfrm>
-            <a:off x="3943350" y="4343400"/>
-            <a:ext cx="619125" cy="228600"/>
+              <a:t>HTTP/2 SBI</a:t>
+            </a:r>
+            <a:endParaRPr lang="zh-TW" sz="1050"/>
+          </a:p>
+        </p:txBody>
+      </p:sp>
+      <p:sp>
+        <p:nvSpPr>
+          <p:cNvPr id="68" name="n4-name"/>
+          <p:cNvSpPr txBox="1"/>
+          <p:nvPr/>
+        </p:nvSpPr>
+        <p:spPr>
+          <a:xfrm>
+            <a:off x="3943350" y="4105275"/>
+            <a:ext cx="1476375" cy="228600"/>
           </a:xfrm>
           <a:prstGeom prst="rect">
             <a:avLst/>
@@ -4876,30 +4406,30 @@
               </a:spcAft>
             </a:pPr>
             <a:r>
-              <a:rPr lang="zh-TW" sz="1200" b="0">
-                <a:solidFill>
-                  <a:srgbClr val="5B6575"/>
+              <a:rPr lang="zh-TW" sz="1350" b="1">
+                <a:solidFill>
+                  <a:srgbClr val="14213D"/>
                 </a:solidFill>
                 <a:latin typeface="Noto Sans CJK TC"/>
                 <a:ea typeface="Noto Sans CJK TC"/>
                 <a:cs typeface="Noto Sans CJK TC"/>
               </a:rPr>
-              <a:t>PFCP</a:t>
-            </a:r>
-            <a:endParaRPr lang="zh-TW" sz="1200"/>
-          </a:p>
-        </p:txBody>
-      </p:sp>
-      <p:sp>
-        <p:nvSpPr>
-          <p:cNvPr id="70" name="uu-label"/>
-          <p:cNvSpPr txBox="1"/>
-          <p:nvPr/>
-        </p:nvSpPr>
-        <p:spPr>
-          <a:xfrm>
-            <a:off x="1228725" y="4152900"/>
-            <a:ext cx="666750" cy="409575"/>
+              <a:t>N4</a:t>
+            </a:r>
+            <a:endParaRPr lang="zh-TW" sz="1350"/>
+          </a:p>
+        </p:txBody>
+      </p:sp>
+      <p:sp>
+        <p:nvSpPr>
+          <p:cNvPr id="69" name="n4-protocol"/>
+          <p:cNvSpPr txBox="1"/>
+          <p:nvPr/>
+        </p:nvSpPr>
+        <p:spPr>
+          <a:xfrm>
+            <a:off x="3943350" y="4343400"/>
+            <a:ext cx="619125" cy="228600"/>
           </a:xfrm>
           <a:prstGeom prst="rect">
             <a:avLst/>
@@ -4915,6 +4445,54 @@
           </a:bodyPr>
           <a:lstStyle/>
           <a:p>
+            <a:pPr algn="l">
+              <a:lnSpc>
+                <a:spcPct val="112000"/>
+              </a:lnSpc>
+              <a:spcAft>
+                <a:spcPts val="0"/>
+              </a:spcAft>
+            </a:pPr>
+            <a:r>
+              <a:rPr lang="zh-TW" sz="1200" b="0">
+                <a:solidFill>
+                  <a:srgbClr val="5B6575"/>
+                </a:solidFill>
+                <a:latin typeface="Noto Sans CJK TC"/>
+                <a:ea typeface="Noto Sans CJK TC"/>
+                <a:cs typeface="Noto Sans CJK TC"/>
+              </a:rPr>
+              <a:t>PFCP</a:t>
+            </a:r>
+            <a:endParaRPr lang="zh-TW" sz="1200"/>
+          </a:p>
+        </p:txBody>
+      </p:sp>
+      <p:sp>
+        <p:nvSpPr>
+          <p:cNvPr id="70" name="uu-label"/>
+          <p:cNvSpPr txBox="1"/>
+          <p:nvPr/>
+        </p:nvSpPr>
+        <p:spPr>
+          <a:xfrm>
+            <a:off x="1228725" y="4152900"/>
+            <a:ext cx="666750" cy="409575"/>
+          </a:xfrm>
+          <a:prstGeom prst="rect">
+            <a:avLst/>
+          </a:prstGeom>
+          <a:noFill/>
+          <a:ln>
+            <a:noFill/>
+          </a:ln>
+        </p:spPr>
+        <p:txBody>
+          <a:bodyPr wrap="none" lIns="0" rIns="0" tIns="0" bIns="0" anchor="t">
+            <a:noAutofit/>
+          </a:bodyPr>
+          <a:lstStyle/>
+          <a:p>
             <a:pPr algn="ctr">
               <a:lnSpc>
                 <a:spcPct val="112000"/>
@@ -5228,14 +4806,14 @@
       </p:sp>
       <p:sp>
         <p:nvSpPr>
-          <p:cNvPr id="78" name="custom-media-requirements"/>
-          <p:cNvSpPr txBox="1"/>
-          <p:nvPr/>
-        </p:nvSpPr>
-        <p:spPr>
-          <a:xfrm>
-            <a:off x="6534150" y="4095750"/>
-            <a:ext cx="714375" cy="428625"/>
+          <p:cNvPr id="77" name="custom-api-scope"/>
+          <p:cNvSpPr txBox="1"/>
+          <p:nvPr/>
+        </p:nvSpPr>
+        <p:spPr>
+          <a:xfrm>
+            <a:off x="7486650" y="3209925"/>
+            <a:ext cx="2324100" cy="200025"/>
           </a:xfrm>
           <a:prstGeom prst="rect">
             <a:avLst/>
@@ -5251,6 +4829,54 @@
           </a:bodyPr>
           <a:lstStyle/>
           <a:p>
+            <a:pPr algn="l">
+              <a:lnSpc>
+                <a:spcPct val="112000"/>
+              </a:lnSpc>
+              <a:spcAft>
+                <a:spcPts val="0"/>
+              </a:spcAft>
+            </a:pPr>
+            <a:r>
+              <a:rPr lang="zh-TW" sz="1050" b="0">
+                <a:solidFill>
+                  <a:srgbClr val="786B65"/>
+                </a:solidFill>
+                <a:latin typeface="Noto Sans CJK TC"/>
+                <a:ea typeface="Noto Sans CJK TC"/>
+                <a:cs typeface="Noto Sans CJK TC"/>
+              </a:rPr>
+              <a:t>implementation-specific</a:t>
+            </a:r>
+            <a:endParaRPr lang="zh-TW" sz="1050"/>
+          </a:p>
+        </p:txBody>
+      </p:sp>
+      <p:sp>
+        <p:nvSpPr>
+          <p:cNvPr id="78" name="custom-media-requirements"/>
+          <p:cNvSpPr txBox="1"/>
+          <p:nvPr/>
+        </p:nvSpPr>
+        <p:spPr>
+          <a:xfrm>
+            <a:off x="6534150" y="4095750"/>
+            <a:ext cx="714375" cy="428625"/>
+          </a:xfrm>
+          <a:prstGeom prst="rect">
+            <a:avLst/>
+          </a:prstGeom>
+          <a:noFill/>
+          <a:ln>
+            <a:noFill/>
+          </a:ln>
+        </p:spPr>
+        <p:txBody>
+          <a:bodyPr wrap="none" lIns="0" rIns="0" tIns="0" bIns="0" anchor="t">
+            <a:noAutofit/>
+          </a:bodyPr>
+          <a:lstStyle/>
+          <a:p>
             <a:pPr algn="ctr">
               <a:lnSpc>
                 <a:spcPct val="112000"/>
@@ -5438,14 +5064,14 @@
       </p:sp>
       <p:sp>
         <p:nvSpPr>
-          <p:cNvPr id="83" name="gm-label"/>
-          <p:cNvSpPr txBox="1"/>
-          <p:nvPr/>
-        </p:nvSpPr>
-        <p:spPr>
-          <a:xfrm>
-            <a:off x="1638300" y="5543550"/>
-            <a:ext cx="5476875" cy="257175"/>
+          <p:cNvPr id="81" name="cx-i-label"/>
+          <p:cNvSpPr txBox="1"/>
+          <p:nvPr/>
+        </p:nvSpPr>
+        <p:spPr>
+          <a:xfrm>
+            <a:off x="9210675" y="4267200"/>
+            <a:ext cx="752475" cy="333375"/>
           </a:xfrm>
           <a:prstGeom prst="rect">
             <a:avLst/>
@@ -5461,6 +5087,146 @@
           </a:bodyPr>
           <a:lstStyle/>
           <a:p>
+            <a:pPr algn="ctr">
+              <a:lnSpc>
+                <a:spcPct val="112000"/>
+              </a:lnSpc>
+              <a:spcAft>
+                <a:spcPts val="0"/>
+              </a:spcAft>
+            </a:pPr>
+            <a:r>
+              <a:rPr lang="zh-TW" sz="975" b="0">
+                <a:solidFill>
+                  <a:srgbClr val="7D8795"/>
+                </a:solidFill>
+                <a:latin typeface="Noto Sans CJK TC"/>
+                <a:ea typeface="Noto Sans CJK TC"/>
+                <a:cs typeface="Noto Sans CJK TC"/>
+              </a:rPr>
+              <a:t>Cx</a:t>
+            </a:r>
+            <a:endParaRPr lang="zh-TW" sz="975"/>
+          </a:p>
+          <a:p>
+            <a:pPr algn="ctr">
+              <a:lnSpc>
+                <a:spcPct val="112000"/>
+              </a:lnSpc>
+              <a:spcAft>
+                <a:spcPts val="0"/>
+              </a:spcAft>
+            </a:pPr>
+            <a:r>
+              <a:rPr lang="zh-TW" sz="975" b="0">
+                <a:solidFill>
+                  <a:srgbClr val="7D8795"/>
+                </a:solidFill>
+                <a:latin typeface="Noto Sans CJK TC"/>
+                <a:ea typeface="Noto Sans CJK TC"/>
+                <a:cs typeface="Noto Sans CJK TC"/>
+              </a:rPr>
+              <a:t>Diameter</a:t>
+            </a:r>
+            <a:endParaRPr lang="zh-TW" sz="975"/>
+          </a:p>
+        </p:txBody>
+      </p:sp>
+      <p:sp>
+        <p:nvSpPr>
+          <p:cNvPr id="82" name="cx-s-label"/>
+          <p:cNvSpPr txBox="1"/>
+          <p:nvPr/>
+        </p:nvSpPr>
+        <p:spPr>
+          <a:xfrm>
+            <a:off x="10944225" y="4276725"/>
+            <a:ext cx="685800" cy="333375"/>
+          </a:xfrm>
+          <a:prstGeom prst="rect">
+            <a:avLst/>
+          </a:prstGeom>
+          <a:noFill/>
+          <a:ln>
+            <a:noFill/>
+          </a:ln>
+        </p:spPr>
+        <p:txBody>
+          <a:bodyPr wrap="none" lIns="0" rIns="0" tIns="0" bIns="0" anchor="t">
+            <a:noAutofit/>
+          </a:bodyPr>
+          <a:lstStyle/>
+          <a:p>
+            <a:pPr algn="ctr">
+              <a:lnSpc>
+                <a:spcPct val="112000"/>
+              </a:lnSpc>
+              <a:spcAft>
+                <a:spcPts val="0"/>
+              </a:spcAft>
+            </a:pPr>
+            <a:r>
+              <a:rPr lang="zh-TW" sz="975" b="0">
+                <a:solidFill>
+                  <a:srgbClr val="7D8795"/>
+                </a:solidFill>
+                <a:latin typeface="Noto Sans CJK TC"/>
+                <a:ea typeface="Noto Sans CJK TC"/>
+                <a:cs typeface="Noto Sans CJK TC"/>
+              </a:rPr>
+              <a:t>Cx</a:t>
+            </a:r>
+            <a:endParaRPr lang="zh-TW" sz="975"/>
+          </a:p>
+          <a:p>
+            <a:pPr algn="ctr">
+              <a:lnSpc>
+                <a:spcPct val="112000"/>
+              </a:lnSpc>
+              <a:spcAft>
+                <a:spcPts val="0"/>
+              </a:spcAft>
+            </a:pPr>
+            <a:r>
+              <a:rPr lang="zh-TW" sz="975" b="0">
+                <a:solidFill>
+                  <a:srgbClr val="7D8795"/>
+                </a:solidFill>
+                <a:latin typeface="Noto Sans CJK TC"/>
+                <a:ea typeface="Noto Sans CJK TC"/>
+                <a:cs typeface="Noto Sans CJK TC"/>
+              </a:rPr>
+              <a:t>Diameter</a:t>
+            </a:r>
+            <a:endParaRPr lang="zh-TW" sz="975"/>
+          </a:p>
+        </p:txBody>
+      </p:sp>
+      <p:sp>
+        <p:nvSpPr>
+          <p:cNvPr id="83" name="gm-label"/>
+          <p:cNvSpPr txBox="1"/>
+          <p:nvPr/>
+        </p:nvSpPr>
+        <p:spPr>
+          <a:xfrm>
+            <a:off x="1638300" y="5543550"/>
+            <a:ext cx="5476875" cy="257175"/>
+          </a:xfrm>
+          <a:prstGeom prst="rect">
+            <a:avLst/>
+          </a:prstGeom>
+          <a:noFill/>
+          <a:ln>
+            <a:noFill/>
+          </a:ln>
+        </p:spPr>
+        <p:txBody>
+          <a:bodyPr wrap="none" lIns="0" rIns="0" tIns="0" bIns="0" anchor="t">
+            <a:noAutofit/>
+          </a:bodyPr>
+          <a:lstStyle/>
+          <a:p>
             <a:pPr algn="l">
               <a:lnSpc>
                 <a:spcPct val="112000"/>
@@ -5573,6 +5339,168 @@
               <a:t>經 gNB、UPF 進入 DN</a:t>
             </a:r>
             <a:endParaRPr lang="zh-TW" sz="1275"/>
+          </a:p>
+        </p:txBody>
+      </p:sp>
+      <p:sp>
+        <p:nvSpPr>
+          <p:cNvPr id="85" name="ran-note"/>
+          <p:cNvSpPr txBox="1"/>
+          <p:nvPr/>
+        </p:nvSpPr>
+        <p:spPr>
+          <a:xfrm>
+            <a:off x="619125" y="3095625"/>
+            <a:ext cx="1885950" cy="666750"/>
+          </a:xfrm>
+          <a:prstGeom prst="rect">
+            <a:avLst/>
+          </a:prstGeom>
+          <a:noFill/>
+          <a:ln>
+            <a:noFill/>
+          </a:ln>
+        </p:spPr>
+        <p:txBody>
+          <a:bodyPr wrap="none" lIns="0" rIns="0" tIns="0" bIns="0" anchor="t">
+            <a:noAutofit/>
+          </a:bodyPr>
+          <a:lstStyle/>
+          <a:p>
+            <a:pPr algn="l">
+              <a:lnSpc>
+                <a:spcPct val="112000"/>
+              </a:lnSpc>
+              <a:spcAft>
+                <a:spcPts val="0"/>
+              </a:spcAft>
+            </a:pPr>
+            <a:r>
+              <a:rPr lang="zh-TW" sz="1125" b="0">
+                <a:solidFill>
+                  <a:srgbClr val="5B6575"/>
+                </a:solidFill>
+                <a:latin typeface="Noto Sans CJK TC"/>
+                <a:ea typeface="Noto Sans CJK TC"/>
+                <a:cs typeface="Noto Sans CJK TC"/>
+              </a:rPr>
+              <a:t>本 PoC：free-ran-ue</a:t>
+            </a:r>
+            <a:endParaRPr lang="zh-TW" sz="1125"/>
+          </a:p>
+          <a:p>
+            <a:pPr algn="l">
+              <a:lnSpc>
+                <a:spcPct val="112000"/>
+              </a:lnSpc>
+              <a:spcAft>
+                <a:spcPts val="0"/>
+              </a:spcAft>
+            </a:pPr>
+            <a:r>
+              <a:rPr lang="zh-TW" sz="1125" b="0">
+                <a:solidFill>
+                  <a:srgbClr val="5B6575"/>
+                </a:solidFill>
+                <a:latin typeface="Noto Sans CJK TC"/>
+                <a:ea typeface="Noto Sans CJK TC"/>
+                <a:cs typeface="Noto Sans CJK TC"/>
+              </a:rPr>
+              <a:t>模擬 UE / gNB</a:t>
+            </a:r>
+            <a:endParaRPr lang="zh-TW" sz="1125"/>
+          </a:p>
+          <a:p>
+            <a:pPr algn="l">
+              <a:lnSpc>
+                <a:spcPct val="112000"/>
+              </a:lnSpc>
+              <a:spcAft>
+                <a:spcPts val="0"/>
+              </a:spcAft>
+            </a:pPr>
+            <a:r>
+              <a:rPr lang="zh-TW" sz="1125" b="0">
+                <a:solidFill>
+                  <a:srgbClr val="5B6575"/>
+                </a:solidFill>
+                <a:latin typeface="Noto Sans CJK TC"/>
+                <a:ea typeface="Noto Sans CJK TC"/>
+                <a:cs typeface="Noto Sans CJK TC"/>
+              </a:rPr>
+              <a:t>Uu 為邏輯示意</a:t>
+            </a:r>
+            <a:endParaRPr lang="zh-TW" sz="1125"/>
+          </a:p>
+        </p:txBody>
+      </p:sp>
+      <p:sp>
+        <p:nvSpPr>
+          <p:cNvPr id="86" name="arrow-note"/>
+          <p:cNvSpPr txBox="1"/>
+          <p:nvPr/>
+        </p:nvSpPr>
+        <p:spPr>
+          <a:xfrm>
+            <a:off x="7791450" y="5581650"/>
+            <a:ext cx="3905250" cy="371475"/>
+          </a:xfrm>
+          <a:prstGeom prst="rect">
+            <a:avLst/>
+          </a:prstGeom>
+          <a:noFill/>
+          <a:ln>
+            <a:noFill/>
+          </a:ln>
+        </p:spPr>
+        <p:txBody>
+          <a:bodyPr wrap="none" lIns="0" rIns="0" tIns="0" bIns="0" anchor="t">
+            <a:noAutofit/>
+          </a:bodyPr>
+          <a:lstStyle/>
+          <a:p>
+            <a:pPr algn="l">
+              <a:lnSpc>
+                <a:spcPct val="112000"/>
+              </a:lnSpc>
+              <a:spcAft>
+                <a:spcPts val="0"/>
+              </a:spcAft>
+            </a:pPr>
+            <a:r>
+              <a:rPr lang="zh-TW" sz="1050" b="0">
+                <a:solidFill>
+                  <a:srgbClr val="5B6575"/>
+                </a:solidFill>
+                <a:latin typeface="Noto Sans CJK TC"/>
+                <a:ea typeface="Noto Sans CJK TC"/>
+                <a:cs typeface="Noto Sans CJK TC"/>
+              </a:rPr>
+              <a:t>箭頭：請求／政策下發方向；回應省略。</a:t>
+            </a:r>
+            <a:endParaRPr lang="zh-TW" sz="1050"/>
+          </a:p>
+          <a:p>
+            <a:pPr algn="l">
+              <a:lnSpc>
+                <a:spcPct val="112000"/>
+              </a:lnSpc>
+              <a:spcAft>
+                <a:spcPts val="0"/>
+              </a:spcAft>
+            </a:pPr>
+            <a:r>
+              <a:rPr lang="zh-TW" sz="1050" b="0">
+                <a:solidFill>
+                  <a:srgbClr val="5B6575"/>
+                </a:solidFill>
+                <a:latin typeface="Noto Sans CJK TC"/>
+                <a:ea typeface="Noto Sans CJK TC"/>
+                <a:cs typeface="Noto Sans CJK TC"/>
+              </a:rPr>
+              <a:t>P → I → S 為本專案的 SIP 路由。</a:t>
+            </a:r>
+            <a:endParaRPr lang="zh-TW" sz="1050"/>
           </a:p>
         </p:txBody>
       </p:sp>
@@ -10122,732 +10050,6 @@
 </p:sld>
 </file>
 
-<file path=ppt/slides/slide18.xml><?xml version="1.0" encoding="utf-8"?>
-<p:sld xmlns:a="http://schemas.openxmlformats.org/drawingml/2006/main" xmlns:r="http://schemas.openxmlformats.org/officeDocument/2006/relationships" xmlns:p="http://schemas.openxmlformats.org/presentationml/2006/main">
-  <p:cSld>
-    <p:bg>
-      <p:bgPr>
-        <a:solidFill>
-          <a:srgbClr val="F6F7F9"/>
-        </a:solidFill>
-        <a:effectLst/>
-      </p:bgPr>
-    </p:bg>
-    <p:spTree>
-      <p:nvGrpSpPr>
-        <p:cNvPr id="1" name=""/>
-        <p:cNvGrpSpPr/>
-        <p:nvPr/>
-      </p:nvGrpSpPr>
-      <p:grpSpPr>
-        <a:xfrm>
-          <a:off x="0" y="0"/>
-          <a:ext cx="0" cy="0"/>
-          <a:chOff x="0" y="0"/>
-          <a:chExt cx="0" cy="0"/>
-        </a:xfrm>
-      </p:grpSpPr>
-      <p:sp>
-        <p:nvSpPr>
-          <p:cNvPr id="3" name="Shape 3">
-            <a:extLst>
-              <a:ext uri="{FF2B5EF4-FFF2-40B4-BE49-F238E27FC236}">
-                <a16:creationId xmlns:a16="http://schemas.microsoft.com/office/drawing/2014/main" id="{5D11F19D-0FC9-46E2-B1FE-ED29AA4C19EC}"/>
-              </a:ext>
-            </a:extLst>
-          </p:cNvPr>
-          <p:cNvSpPr/>
-          <p:nvPr/>
-        </p:nvSpPr>
-        <p:spPr>
-          <a:xfrm>
-            <a:off x="666750" y="1524000"/>
-            <a:ext cx="1981200" cy="3657600"/>
-          </a:xfrm>
-          <a:prstGeom prst="roundRect">
-            <a:avLst/>
-          </a:prstGeom>
-          <a:solidFill>
-            <a:srgbClr val="FFFFFF"/>
-          </a:solidFill>
-          <a:ln w="12700">
-            <a:solidFill>
-              <a:srgbClr val="D5DAE1"/>
-            </a:solidFill>
-          </a:ln>
-        </p:spPr>
-        <p:txBody>
-          <a:bodyPr wrap="square" rtlCol="0"/>
-          <a:lstStyle/>
-          <a:p>
-            <a:r>
-              <a:rPr/>
-              <a:t/>
-            </a:r>
-          </a:p>
-        </p:txBody>
-      </p:sp>
-      <p:sp>
-        <p:nvSpPr>
-          <p:cNvPr id="4" name="Shape 4">
-            <a:extLst>
-              <a:ext uri="{FF2B5EF4-FFF2-40B4-BE49-F238E27FC236}">
-                <a16:creationId xmlns:a16="http://schemas.microsoft.com/office/drawing/2014/main" id="{98E750CC-341C-450F-9C13-780410886805}"/>
-              </a:ext>
-            </a:extLst>
-          </p:cNvPr>
-          <p:cNvSpPr/>
-          <p:nvPr/>
-        </p:nvSpPr>
-        <p:spPr>
-          <a:xfrm>
-            <a:off x="2886075" y="1524000"/>
-            <a:ext cx="1981200" cy="3657600"/>
-          </a:xfrm>
-          <a:prstGeom prst="roundRect">
-            <a:avLst/>
-          </a:prstGeom>
-          <a:solidFill>
-            <a:srgbClr val="FFFFFF"/>
-          </a:solidFill>
-          <a:ln w="12700">
-            <a:solidFill>
-              <a:srgbClr val="D5DAE1"/>
-            </a:solidFill>
-          </a:ln>
-        </p:spPr>
-        <p:txBody>
-          <a:bodyPr wrap="square" rtlCol="0"/>
-          <a:lstStyle/>
-          <a:p>
-            <a:r>
-              <a:rPr/>
-              <a:t/>
-            </a:r>
-          </a:p>
-        </p:txBody>
-      </p:sp>
-      <p:sp>
-        <p:nvSpPr>
-          <p:cNvPr id="5" name="Shape 5">
-            <a:extLst>
-              <a:ext uri="{FF2B5EF4-FFF2-40B4-BE49-F238E27FC236}">
-                <a16:creationId xmlns:a16="http://schemas.microsoft.com/office/drawing/2014/main" id="{E2270AE8-D148-4054-AA79-97735C690245}"/>
-              </a:ext>
-            </a:extLst>
-          </p:cNvPr>
-          <p:cNvSpPr/>
-          <p:nvPr/>
-        </p:nvSpPr>
-        <p:spPr>
-          <a:xfrm>
-            <a:off x="5105400" y="1524000"/>
-            <a:ext cx="1981200" cy="3657600"/>
-          </a:xfrm>
-          <a:prstGeom prst="roundRect">
-            <a:avLst/>
-          </a:prstGeom>
-          <a:solidFill>
-            <a:srgbClr val="FCEBDD"/>
-          </a:solidFill>
-        </p:spPr>
-        <p:txBody>
-          <a:bodyPr wrap="square" rtlCol="0"/>
-          <a:lstStyle/>
-          <a:p>
-            <a:r>
-              <a:rPr/>
-              <a:t/>
-            </a:r>
-          </a:p>
-        </p:txBody>
-      </p:sp>
-      <p:sp>
-        <p:nvSpPr>
-          <p:cNvPr id="6" name="Shape 6">
-            <a:extLst>
-              <a:ext uri="{FF2B5EF4-FFF2-40B4-BE49-F238E27FC236}">
-                <a16:creationId xmlns:a16="http://schemas.microsoft.com/office/drawing/2014/main" id="{7BED27BB-0645-4EA6-BEB4-3FB21FC96BBE}"/>
-              </a:ext>
-            </a:extLst>
-          </p:cNvPr>
-          <p:cNvSpPr/>
-          <p:nvPr/>
-        </p:nvSpPr>
-        <p:spPr>
-          <a:xfrm>
-            <a:off x="7324725" y="1524000"/>
-            <a:ext cx="1981200" cy="3657600"/>
-          </a:xfrm>
-          <a:prstGeom prst="roundRect">
-            <a:avLst/>
-          </a:prstGeom>
-          <a:solidFill>
-            <a:srgbClr val="FFFFFF"/>
-          </a:solidFill>
-          <a:ln w="12700">
-            <a:solidFill>
-              <a:srgbClr val="D5DAE1"/>
-            </a:solidFill>
-          </a:ln>
-        </p:spPr>
-        <p:txBody>
-          <a:bodyPr wrap="square" rtlCol="0"/>
-          <a:lstStyle/>
-          <a:p>
-            <a:r>
-              <a:rPr/>
-              <a:t/>
-            </a:r>
-          </a:p>
-        </p:txBody>
-      </p:sp>
-      <p:sp>
-        <p:nvSpPr>
-          <p:cNvPr id="7" name="Shape 7">
-            <a:extLst>
-              <a:ext uri="{FF2B5EF4-FFF2-40B4-BE49-F238E27FC236}">
-                <a16:creationId xmlns:a16="http://schemas.microsoft.com/office/drawing/2014/main" id="{4AC050AC-5FCD-493E-8E97-828378DFF6F0}"/>
-              </a:ext>
-            </a:extLst>
-          </p:cNvPr>
-          <p:cNvSpPr/>
-          <p:nvPr/>
-        </p:nvSpPr>
-        <p:spPr>
-          <a:xfrm>
-            <a:off x="9544050" y="1524000"/>
-            <a:ext cx="1981200" cy="3657600"/>
-          </a:xfrm>
-          <a:prstGeom prst="roundRect">
-            <a:avLst/>
-          </a:prstGeom>
-          <a:solidFill>
-            <a:srgbClr val="FFFFFF"/>
-          </a:solidFill>
-          <a:ln w="12700">
-            <a:solidFill>
-              <a:srgbClr val="D5DAE1"/>
-            </a:solidFill>
-          </a:ln>
-        </p:spPr>
-        <p:txBody>
-          <a:bodyPr wrap="square" rtlCol="0"/>
-          <a:lstStyle/>
-          <a:p>
-            <a:r>
-              <a:rPr/>
-              <a:t/>
-            </a:r>
-          </a:p>
-        </p:txBody>
-      </p:sp>
-      <p:sp>
-        <p:nvSpPr>
-          <p:cNvPr id="8" name="TextBox 8">
-            <a:extLst>
-              <a:ext uri="{FF2B5EF4-FFF2-40B4-BE49-F238E27FC236}">
-                <a16:creationId xmlns:a16="http://schemas.microsoft.com/office/drawing/2014/main" id="{D279A7D9-468E-41F1-8EF0-AA4BC50D023C}"/>
-              </a:ext>
-            </a:extLst>
-          </p:cNvPr>
-          <p:cNvSpPr txBox="1"/>
-          <p:nvPr/>
-        </p:nvSpPr>
-        <p:spPr>
-          <a:xfrm>
-            <a:off x="666750" y="533400"/>
-            <a:ext cx="10858500" cy="609600"/>
-          </a:xfrm>
-        </p:spPr>
-        <p:txBody>
-          <a:bodyPr wrap="square" rtlCol="0" lIns="0" tIns="0" rIns="0" bIns="0" anchor="t">
-            <a:spAutoFit/>
-          </a:bodyPr>
-          <a:lstStyle/>
-          <a:p>
-            <a:r>
-              <a:rPr sz="3600" b="1">
-                <a:solidFill>
-                  <a:srgbClr val="14213D"/>
-                </a:solidFill>
-              </a:rPr>
-              <a:t>現行 AF shim 的五個問題</a:t>
-            </a:r>
-          </a:p>
-        </p:txBody>
-      </p:sp>
-      <p:sp>
-        <p:nvSpPr>
-          <p:cNvPr id="9" name="TextBox 9">
-            <a:extLst>
-              <a:ext uri="{FF2B5EF4-FFF2-40B4-BE49-F238E27FC236}">
-                <a16:creationId xmlns:a16="http://schemas.microsoft.com/office/drawing/2014/main" id="{816D58DF-9530-486D-B41B-FC79396A494F}"/>
-              </a:ext>
-            </a:extLst>
-          </p:cNvPr>
-          <p:cNvSpPr txBox="1"/>
-          <p:nvPr/>
-        </p:nvSpPr>
-        <p:spPr>
-          <a:xfrm>
-            <a:off x="819150" y="1714500"/>
-            <a:ext cx="1676400" cy="3333750"/>
-          </a:xfrm>
-        </p:spPr>
-        <p:txBody>
-          <a:bodyPr wrap="square" rtlCol="0" lIns="0" tIns="0" rIns="0" bIns="0" anchor="t">
-            <a:spAutoFit/>
-          </a:bodyPr>
-          <a:lstStyle/>
-          <a:p>
-            <a:pPr>
-              <a:spcAft>
-                <a:spcPts val="600"/>
-              </a:spcAft>
-            </a:pPr>
-            <a:r>
-              <a:rPr sz="4000" b="1">
-                <a:solidFill>
-                  <a:srgbClr val="E8742A"/>
-                </a:solidFill>
-              </a:rPr>
-              <a:t>01</a:t>
-            </a:r>
-          </a:p>
-          <a:p>
-            <a:pPr>
-              <a:spcAft>
-                <a:spcPts val="1200"/>
-              </a:spcAft>
-            </a:pPr>
-            <a:r>
-              <a:rPr sz="1800" b="1">
-                <a:solidFill>
-                  <a:srgbClr val="14213D"/>
-                </a:solidFill>
-              </a:rPr>
-              <a:t>自訂 JSON 介面</a:t>
-            </a:r>
-          </a:p>
-          <a:p>
-            <a:pPr>
-              <a:lnSpc>
-                <a:spcPct val="125000"/>
-              </a:lnSpc>
-              <a:spcAft>
-                <a:spcPts val="2000"/>
-              </a:spcAft>
-            </a:pPr>
-            <a:r>
-              <a:rPr sz="1800">
-                <a:solidFill>
-                  <a:srgbClr val="5B6575"/>
-                </a:solidFill>
-              </a:rPr>
-              <a:t>換掉任一端都要重寫</a:t>
-            </a:r>
-          </a:p>
-          <a:p>
-            <a:r>
-              <a:rPr sz="1500">
-                <a:solidFill>
-                  <a:srgbClr val="0F4C81"/>
-                </a:solidFill>
-              </a:rPr>
-              <a:t>route[AF_RESERVE]</a:t>
-            </a:r>
-          </a:p>
-        </p:txBody>
-      </p:sp>
-      <p:sp>
-        <p:nvSpPr>
-          <p:cNvPr id="10" name="TextBox 10">
-            <a:extLst>
-              <a:ext uri="{FF2B5EF4-FFF2-40B4-BE49-F238E27FC236}">
-                <a16:creationId xmlns:a16="http://schemas.microsoft.com/office/drawing/2014/main" id="{BAFD657C-6F32-4AEC-8DEC-EE838239AD60}"/>
-              </a:ext>
-            </a:extLst>
-          </p:cNvPr>
-          <p:cNvSpPr txBox="1"/>
-          <p:nvPr/>
-        </p:nvSpPr>
-        <p:spPr>
-          <a:xfrm>
-            <a:off x="3038475" y="1714500"/>
-            <a:ext cx="1676400" cy="3333750"/>
-          </a:xfrm>
-        </p:spPr>
-        <p:txBody>
-          <a:bodyPr wrap="square" rtlCol="0" lIns="0" tIns="0" rIns="0" bIns="0" anchor="t">
-            <a:spAutoFit/>
-          </a:bodyPr>
-          <a:lstStyle/>
-          <a:p>
-            <a:pPr>
-              <a:spcAft>
-                <a:spcPts val="600"/>
-              </a:spcAft>
-            </a:pPr>
-            <a:r>
-              <a:rPr sz="4000" b="1">
-                <a:solidFill>
-                  <a:srgbClr val="E8742A"/>
-                </a:solidFill>
-              </a:rPr>
-              <a:t>02</a:t>
-            </a:r>
-          </a:p>
-          <a:p>
-            <a:pPr>
-              <a:spcAft>
-                <a:spcPts val="1200"/>
-              </a:spcAft>
-            </a:pPr>
-            <a:r>
-              <a:rPr sz="1800" b="1">
-                <a:solidFill>
-                  <a:srgbClr val="14213D"/>
-                </a:solidFill>
-              </a:rPr>
-              <a:t>AF 邏輯散在 cfg</a:t>
-            </a:r>
-          </a:p>
-          <a:p>
-            <a:pPr>
-              <a:lnSpc>
-                <a:spcPct val="125000"/>
-              </a:lnSpc>
-              <a:spcAft>
-                <a:spcPts val="2000"/>
-              </a:spcAft>
-            </a:pPr>
-            <a:r>
-              <a:rPr sz="1800">
-                <a:solidFill>
-                  <a:srgbClr val="5B6575"/>
-                </a:solidFill>
-              </a:rPr>
-              <a:t>寫在 SIP 路由腳本，難測試</a:t>
-            </a:r>
-          </a:p>
-          <a:p>
-            <a:r>
-              <a:rPr sz="1500">
-                <a:solidFill>
-                  <a:srgbClr val="0F4C81"/>
-                </a:solidFill>
-              </a:rPr>
-              <a:t>AF_KEY / AF_RELEASE</a:t>
-            </a:r>
-          </a:p>
-        </p:txBody>
-      </p:sp>
-      <p:sp>
-        <p:nvSpPr>
-          <p:cNvPr id="11" name="TextBox 11">
-            <a:extLst>
-              <a:ext uri="{FF2B5EF4-FFF2-40B4-BE49-F238E27FC236}">
-                <a16:creationId xmlns:a16="http://schemas.microsoft.com/office/drawing/2014/main" id="{E18DBFF2-0020-41F1-8976-553B0C2D007C}"/>
-              </a:ext>
-            </a:extLst>
-          </p:cNvPr>
-          <p:cNvSpPr txBox="1"/>
-          <p:nvPr/>
-        </p:nvSpPr>
-        <p:spPr>
-          <a:xfrm>
-            <a:off x="5257800" y="1714500"/>
-            <a:ext cx="1676400" cy="3333750"/>
-          </a:xfrm>
-        </p:spPr>
-        <p:txBody>
-          <a:bodyPr wrap="square" rtlCol="0" lIns="0" tIns="0" rIns="0" bIns="0" anchor="t">
-            <a:spAutoFit/>
-          </a:bodyPr>
-          <a:lstStyle/>
-          <a:p>
-            <a:pPr>
-              <a:spcAft>
-                <a:spcPts val="600"/>
-              </a:spcAft>
-            </a:pPr>
-            <a:r>
-              <a:rPr sz="4000" b="1">
-                <a:solidFill>
-                  <a:srgbClr val="E8742A"/>
-                </a:solidFill>
-              </a:rPr>
-              <a:t>03</a:t>
-            </a:r>
-          </a:p>
-          <a:p>
-            <a:pPr>
-              <a:spcAft>
-                <a:spcPts val="1200"/>
-              </a:spcAft>
-            </a:pPr>
-            <a:r>
-              <a:rPr sz="1800" b="1">
-                <a:solidFill>
-                  <a:srgbClr val="14213D"/>
-                </a:solidFill>
-              </a:rPr>
-              <a:t>PCF 通知只寫 log</a:t>
-            </a:r>
-          </a:p>
-          <a:p>
-            <a:pPr>
-              <a:lnSpc>
-                <a:spcPct val="125000"/>
-              </a:lnSpc>
-              <a:spcAft>
-                <a:spcPts val="2000"/>
-              </a:spcAft>
-            </a:pPr>
-            <a:r>
-              <a:rPr sz="1800">
-                <a:solidFill>
-                  <a:srgbClr val="5B6575"/>
-                </a:solidFill>
-              </a:rPr>
-              <a:t>PDU session 沒了，通話還掛著</a:t>
-            </a:r>
-          </a:p>
-          <a:p>
-            <a:r>
-              <a:rPr sz="1500">
-                <a:solidFill>
-                  <a:srgbClr val="0F4C81"/>
-                </a:solidFill>
-              </a:rPr>
-              <a:t>handleNotify → 204</a:t>
-            </a:r>
-          </a:p>
-        </p:txBody>
-      </p:sp>
-      <p:sp>
-        <p:nvSpPr>
-          <p:cNvPr id="12" name="TextBox 12">
-            <a:extLst>
-              <a:ext uri="{FF2B5EF4-FFF2-40B4-BE49-F238E27FC236}">
-                <a16:creationId xmlns:a16="http://schemas.microsoft.com/office/drawing/2014/main" id="{EE9EC9A7-8AAE-48E6-93AD-4293CED6C987}"/>
-              </a:ext>
-            </a:extLst>
-          </p:cNvPr>
-          <p:cNvSpPr txBox="1"/>
-          <p:nvPr/>
-        </p:nvSpPr>
-        <p:spPr>
-          <a:xfrm>
-            <a:off x="7477125" y="1714500"/>
-            <a:ext cx="1676400" cy="3333750"/>
-          </a:xfrm>
-        </p:spPr>
-        <p:txBody>
-          <a:bodyPr wrap="square" rtlCol="0" lIns="0" tIns="0" rIns="0" bIns="0" anchor="t">
-            <a:spAutoFit/>
-          </a:bodyPr>
-          <a:lstStyle/>
-          <a:p>
-            <a:pPr>
-              <a:spcAft>
-                <a:spcPts val="600"/>
-              </a:spcAft>
-            </a:pPr>
-            <a:r>
-              <a:rPr sz="4000" b="1">
-                <a:solidFill>
-                  <a:srgbClr val="E8742A"/>
-                </a:solidFill>
-              </a:rPr>
-              <a:t>04</a:t>
-            </a:r>
-          </a:p>
-          <a:p>
-            <a:pPr>
-              <a:spcAft>
-                <a:spcPts val="1200"/>
-              </a:spcAft>
-            </a:pPr>
-            <a:r>
-              <a:rPr sz="1800" b="1">
-                <a:solidFill>
-                  <a:srgbClr val="14213D"/>
-                </a:solidFill>
-              </a:rPr>
-              <a:t>同步 HTTP 呼叫</a:t>
-            </a:r>
-          </a:p>
-          <a:p>
-            <a:pPr>
-              <a:lnSpc>
-                <a:spcPct val="125000"/>
-              </a:lnSpc>
-              <a:spcAft>
-                <a:spcPts val="2000"/>
-              </a:spcAft>
-            </a:pPr>
-            <a:r>
-              <a:rPr sz="1800">
-                <a:solidFill>
-                  <a:srgbClr val="5B6575"/>
-                </a:solidFill>
-              </a:rPr>
-              <a:t>PCF 慢就卡住 worker</a:t>
-            </a:r>
-          </a:p>
-          <a:p>
-            <a:r>
-              <a:rPr sz="1500">
-                <a:solidFill>
-                  <a:srgbClr val="0F4C81"/>
-                </a:solidFill>
-              </a:rPr>
-              <a:t>http_client_query</a:t>
-            </a:r>
-          </a:p>
-        </p:txBody>
-      </p:sp>
-      <p:sp>
-        <p:nvSpPr>
-          <p:cNvPr id="13" name="TextBox 13">
-            <a:extLst>
-              <a:ext uri="{FF2B5EF4-FFF2-40B4-BE49-F238E27FC236}">
-                <a16:creationId xmlns:a16="http://schemas.microsoft.com/office/drawing/2014/main" id="{3657A981-86DD-4F9E-9A04-EAA9B1C2EA3D}"/>
-              </a:ext>
-            </a:extLst>
-          </p:cNvPr>
-          <p:cNvSpPr txBox="1"/>
-          <p:nvPr/>
-        </p:nvSpPr>
-        <p:spPr>
-          <a:xfrm>
-            <a:off x="9696450" y="1714500"/>
-            <a:ext cx="1676400" cy="3333750"/>
-          </a:xfrm>
-        </p:spPr>
-        <p:txBody>
-          <a:bodyPr wrap="square" rtlCol="0" lIns="0" tIns="0" rIns="0" bIns="0" anchor="t">
-            <a:spAutoFit/>
-          </a:bodyPr>
-          <a:lstStyle/>
-          <a:p>
-            <a:pPr>
-              <a:spcAft>
-                <a:spcPts val="600"/>
-              </a:spcAft>
-            </a:pPr>
-            <a:r>
-              <a:rPr sz="4000" b="1">
-                <a:solidFill>
-                  <a:srgbClr val="E8742A"/>
-                </a:solidFill>
-              </a:rPr>
-              <a:t>05</a:t>
-            </a:r>
-          </a:p>
-          <a:p>
-            <a:pPr>
-              <a:spcAft>
-                <a:spcPts val="1200"/>
-              </a:spcAft>
-            </a:pPr>
-            <a:r>
-              <a:rPr sz="1800" b="1">
-                <a:solidFill>
-                  <a:srgbClr val="14213D"/>
-                </a:solidFill>
-              </a:rPr>
-              <a:t>信令沒有 QoS</a:t>
-            </a:r>
-          </a:p>
-          <a:p>
-            <a:pPr>
-              <a:lnSpc>
-                <a:spcPct val="125000"/>
-              </a:lnSpc>
-              <a:spcAft>
-                <a:spcPts val="2000"/>
-              </a:spcAft>
-            </a:pPr>
-            <a:r>
-              <a:rPr sz="1800">
-                <a:solidFill>
-                  <a:srgbClr val="5B6575"/>
-                </a:solidFill>
-              </a:rPr>
-              <a:t>只預留媒體，信令沒有</a:t>
-            </a:r>
-          </a:p>
-          <a:p>
-            <a:r>
-              <a:rPr sz="1500">
-                <a:solidFill>
-                  <a:srgbClr val="0F4C81"/>
-                </a:solidFill>
-              </a:rPr>
-              <a:t>TS 24.229 / 29.214</a:t>
-            </a:r>
-          </a:p>
-        </p:txBody>
-      </p:sp>
-      <p:sp>
-        <p:nvSpPr>
-          <p:cNvPr id="14" name="Shape 14">
-            <a:extLst>
-              <a:ext uri="{FF2B5EF4-FFF2-40B4-BE49-F238E27FC236}">
-                <a16:creationId xmlns:a16="http://schemas.microsoft.com/office/drawing/2014/main" id="{035EDCCE-686F-4E9E-B2BA-2C1268545101}"/>
-              </a:ext>
-            </a:extLst>
-          </p:cNvPr>
-          <p:cNvSpPr/>
-          <p:nvPr/>
-        </p:nvSpPr>
-        <p:spPr>
-          <a:xfrm>
-            <a:off x="666750" y="5448300"/>
-            <a:ext cx="10858500" cy="800100"/>
-          </a:xfrm>
-          <a:prstGeom prst="roundRect">
-            <a:avLst/>
-          </a:prstGeom>
-          <a:solidFill>
-            <a:srgbClr val="0B1B2E"/>
-          </a:solidFill>
-        </p:spPr>
-        <p:txBody>
-          <a:bodyPr wrap="square" rtlCol="0" lIns="0" tIns="0" rIns="0" bIns="0" anchor="ctr"/>
-          <a:lstStyle/>
-          <a:p>
-            <a:pPr algn="ctr"/>
-            <a:r>
-              <a:rPr sz="1700" b="1">
-                <a:solidFill>
-                  <a:srgbClr val="E8742A"/>
-                </a:solidFill>
-              </a:rPr>
-              <a:t>根本原因：</a:t>
-            </a:r>
-            <a:r>
-              <a:rPr sz="1700">
-                <a:solidFill>
-                  <a:srgbClr val="FFFFFF"/>
-                </a:solidFill>
-              </a:rPr>
-              <a:t>AF 邏輯拆在 cfg 與 shim，兩邊都不是標準介面</a:t>
-            </a:r>
-          </a:p>
-        </p:txBody>
-      </p:sp>
-    </p:spTree>
-  </p:cSld>
-  <p:clrMapOvr>
-    <a:masterClrMapping/>
-  </p:clrMapOvr>
-</p:sld>
-</file>
-
 <file path=ppt/slides/slide19.xml><?xml version="1.0" encoding="utf-8"?>
 <p:sld xmlns:a="http://schemas.openxmlformats.org/drawingml/2006/main" xmlns:r="http://schemas.openxmlformats.org/officeDocument/2006/relationships" xmlns:p="http://schemas.openxmlformats.org/presentationml/2006/main">
   <p:cSld>
@@ -18769,6 +17971,815 @@
 </p:sld>
 </file>
 
+<file path=ppt/slides/slide29.xml><?xml version="1.0" encoding="utf-8"?>
+<p:sld xmlns:a="http://schemas.openxmlformats.org/drawingml/2006/main" xmlns:r="http://schemas.openxmlformats.org/officeDocument/2006/relationships" xmlns:p="http://schemas.openxmlformats.org/presentationml/2006/main">
+  <p:cSld>
+    <p:bg>
+      <p:bgPr>
+        <a:solidFill>
+          <a:srgbClr val="F6F7F9"/>
+        </a:solidFill>
+        <a:effectLst/>
+      </p:bgPr>
+    </p:bg>
+    <p:spTree>
+      <p:nvGrpSpPr>
+        <p:cNvPr id="1" name=""/>
+        <p:cNvGrpSpPr/>
+        <p:nvPr/>
+      </p:nvGrpSpPr>
+      <p:grpSpPr>
+        <a:xfrm>
+          <a:off x="0" y="0"/>
+          <a:ext cx="0" cy="0"/>
+          <a:chOff x="0" y="0"/>
+          <a:chExt cx="0" cy="0"/>
+        </a:xfrm>
+      </p:grpSpPr>
+      <p:sp>
+        <p:nvSpPr>
+          <p:cNvPr id="3" name="Shape 3">
+            <a:extLst>
+              <a:ext uri="{FF2B5EF4-FFF2-40B4-BE49-F238E27FC236}">
+                <a16:creationId xmlns:a16="http://schemas.microsoft.com/office/drawing/2014/main" id="{C2AB672F-B4D9-4A38-9907-07008A22AABB}"/>
+              </a:ext>
+            </a:extLst>
+          </p:cNvPr>
+          <p:cNvSpPr/>
+          <p:nvPr/>
+        </p:nvSpPr>
+        <p:spPr>
+          <a:xfrm>
+            <a:off x="0" y="0"/>
+            <a:ext cx="4000500" cy="6858000"/>
+          </a:xfrm>
+          <a:prstGeom prst="rect">
+            <a:avLst/>
+          </a:prstGeom>
+          <a:solidFill>
+            <a:srgbClr val="0F4C81"/>
+          </a:solidFill>
+        </p:spPr>
+        <p:txBody>
+          <a:bodyPr wrap="square" rtlCol="0"/>
+          <a:lstStyle/>
+          <a:p>
+            <a:r>
+              <a:rPr/>
+              <a:t/>
+            </a:r>
+          </a:p>
+        </p:txBody>
+      </p:sp>
+      <p:sp>
+        <p:nvSpPr>
+          <p:cNvPr id="4" name="TextBox 4">
+            <a:extLst>
+              <a:ext uri="{FF2B5EF4-FFF2-40B4-BE49-F238E27FC236}">
+                <a16:creationId xmlns:a16="http://schemas.microsoft.com/office/drawing/2014/main" id="{5C07153C-4584-4710-BD66-45279AE85757}"/>
+              </a:ext>
+            </a:extLst>
+          </p:cNvPr>
+          <p:cNvSpPr txBox="1"/>
+          <p:nvPr/>
+        </p:nvSpPr>
+        <p:spPr>
+          <a:xfrm>
+            <a:off x="571500" y="1143000"/>
+            <a:ext cx="3048000" cy="2857500"/>
+          </a:xfrm>
+        </p:spPr>
+        <p:txBody>
+          <a:bodyPr wrap="square" rtlCol="0" lIns="0" tIns="0" rIns="0" bIns="0" anchor="t">
+            <a:spAutoFit/>
+          </a:bodyPr>
+          <a:lstStyle/>
+          <a:p>
+            <a:r>
+              <a:rPr sz="16000" b="1">
+                <a:solidFill>
+                  <a:srgbClr val="FFFFFF"/>
+                </a:solidFill>
+              </a:rPr>
+              <a:t>5</a:t>
+            </a:r>
+          </a:p>
+        </p:txBody>
+      </p:sp>
+      <p:sp>
+        <p:nvSpPr>
+          <p:cNvPr id="5" name="TextBox 5">
+            <a:extLst>
+              <a:ext uri="{FF2B5EF4-FFF2-40B4-BE49-F238E27FC236}">
+                <a16:creationId xmlns:a16="http://schemas.microsoft.com/office/drawing/2014/main" id="{B332AD8F-8845-4D7C-A2B1-1D98095CFB1E}"/>
+              </a:ext>
+            </a:extLst>
+          </p:cNvPr>
+          <p:cNvSpPr txBox="1"/>
+          <p:nvPr/>
+        </p:nvSpPr>
+        <p:spPr>
+          <a:xfrm>
+            <a:off x="571500" y="4000500"/>
+            <a:ext cx="3048000" cy="666750"/>
+          </a:xfrm>
+        </p:spPr>
+        <p:txBody>
+          <a:bodyPr wrap="square" rtlCol="0" lIns="0" tIns="0" rIns="0" bIns="0" anchor="t">
+            <a:spAutoFit/>
+          </a:bodyPr>
+          <a:lstStyle/>
+          <a:p>
+            <a:r>
+              <a:rPr sz="2200" b="1">
+                <a:solidFill>
+                  <a:srgbClr val="FFFFFF"/>
+                </a:solidFill>
+              </a:rPr>
+              <a:t>5GC 與 IMS 只有 5 個對接點</a:t>
+            </a:r>
+          </a:p>
+        </p:txBody>
+      </p:sp>
+      <p:sp>
+        <p:nvSpPr>
+          <p:cNvPr id="6" name="TextBox 6">
+            <a:extLst>
+              <a:ext uri="{FF2B5EF4-FFF2-40B4-BE49-F238E27FC236}">
+                <a16:creationId xmlns:a16="http://schemas.microsoft.com/office/drawing/2014/main" id="{E9CC36DB-EBB0-4FD1-8602-E6D39B83A9DE}"/>
+              </a:ext>
+            </a:extLst>
+          </p:cNvPr>
+          <p:cNvSpPr txBox="1"/>
+          <p:nvPr/>
+        </p:nvSpPr>
+        <p:spPr>
+          <a:xfrm>
+            <a:off x="571500" y="4762500"/>
+            <a:ext cx="3143250" cy="1143000"/>
+          </a:xfrm>
+        </p:spPr>
+        <p:txBody>
+          <a:bodyPr wrap="square" rtlCol="0" lIns="0" tIns="0" rIns="0" bIns="0" anchor="t">
+            <a:spAutoFit/>
+          </a:bodyPr>
+          <a:lstStyle/>
+          <a:p>
+            <a:pPr>
+              <a:spcAft>
+                <a:spcPts val="600"/>
+              </a:spcAft>
+            </a:pPr>
+            <a:r>
+              <a:rPr sz="1400">
+                <a:solidFill>
+                  <a:srgbClr val="E8742A"/>
+                </a:solidFill>
+              </a:rPr>
+              <a:t>■ </a:t>
+            </a:r>
+            <a:r>
+              <a:rPr sz="1400">
+                <a:solidFill>
+                  <a:srgbClr val="FFFFFF"/>
+                </a:solidFill>
+              </a:rPr>
+              <a:t>網路介面：N6、PCO、N5</a:t>
+            </a:r>
+          </a:p>
+          <a:p>
+            <a:pPr>
+              <a:spcAft>
+                <a:spcPts val="600"/>
+              </a:spcAft>
+            </a:pPr>
+            <a:r>
+              <a:rPr sz="1400">
+                <a:solidFill>
+                  <a:srgbClr val="C9D3E0"/>
+                </a:solidFill>
+              </a:rPr>
+              <a:t>■ </a:t>
+            </a:r>
+            <a:r>
+              <a:rPr sz="1400">
+                <a:solidFill>
+                  <a:srgbClr val="FFFFFF"/>
+                </a:solidFill>
+              </a:rPr>
+              <a:t>設定與開戶時的對齊：DNN、身分</a:t>
+            </a:r>
+          </a:p>
+          <a:p>
+            <a:r>
+              <a:rPr sz="1400">
+                <a:solidFill>
+                  <a:srgbClr val="C9D3E0"/>
+                </a:solidFill>
+              </a:rPr>
+              <a:t>SIP 不經過 AMF、SMF</a:t>
+            </a:r>
+          </a:p>
+        </p:txBody>
+      </p:sp>
+      <p:sp>
+        <p:nvSpPr>
+          <p:cNvPr id="7" name="Shape 7">
+            <a:extLst>
+              <a:ext uri="{FF2B5EF4-FFF2-40B4-BE49-F238E27FC236}">
+                <a16:creationId xmlns:a16="http://schemas.microsoft.com/office/drawing/2014/main" id="{5E7ED192-C7FB-496A-B550-635F31163665}"/>
+              </a:ext>
+            </a:extLst>
+          </p:cNvPr>
+          <p:cNvSpPr/>
+          <p:nvPr/>
+        </p:nvSpPr>
+        <p:spPr>
+          <a:xfrm>
+            <a:off x="4476750" y="457200"/>
+            <a:ext cx="1047750" cy="457200"/>
+          </a:xfrm>
+          <a:prstGeom prst="roundRect">
+            <a:avLst/>
+          </a:prstGeom>
+          <a:solidFill>
+            <a:srgbClr val="E8742A"/>
+          </a:solidFill>
+        </p:spPr>
+        <p:txBody>
+          <a:bodyPr wrap="square" rtlCol="0" lIns="0" tIns="0" rIns="0" bIns="0" anchor="ctr"/>
+          <a:lstStyle/>
+          <a:p>
+            <a:pPr algn="ctr"/>
+            <a:r>
+              <a:rPr sz="1800" b="1">
+                <a:solidFill>
+                  <a:srgbClr val="FFFFFF"/>
+                </a:solidFill>
+              </a:rPr>
+              <a:t>N6</a:t>
+            </a:r>
+          </a:p>
+        </p:txBody>
+      </p:sp>
+      <p:sp>
+        <p:nvSpPr>
+          <p:cNvPr id="8" name="TextBox 8">
+            <a:extLst>
+              <a:ext uri="{FF2B5EF4-FFF2-40B4-BE49-F238E27FC236}">
+                <a16:creationId xmlns:a16="http://schemas.microsoft.com/office/drawing/2014/main" id="{2BE3260B-4F12-41A4-8745-EBFD3EED351D}"/>
+              </a:ext>
+            </a:extLst>
+          </p:cNvPr>
+          <p:cNvSpPr txBox="1"/>
+          <p:nvPr/>
+        </p:nvSpPr>
+        <p:spPr>
+          <a:xfrm>
+            <a:off x="5762625" y="457200"/>
+            <a:ext cx="5810250" cy="952500"/>
+          </a:xfrm>
+        </p:spPr>
+        <p:txBody>
+          <a:bodyPr wrap="square" rtlCol="0" lIns="0" tIns="0" rIns="0" bIns="0" anchor="t">
+            <a:spAutoFit/>
+          </a:bodyPr>
+          <a:lstStyle/>
+          <a:p>
+            <a:pPr>
+              <a:spcAft>
+                <a:spcPts val="400"/>
+              </a:spcAft>
+            </a:pPr>
+            <a:r>
+              <a:rPr sz="1700" b="1">
+                <a:solidFill>
+                  <a:srgbClr val="14213D"/>
+                </a:solidFill>
+              </a:rPr>
+              <a:t>資料面：SIP 與 RTP 都走 PDU session</a:t>
+            </a:r>
+          </a:p>
+          <a:p>
+            <a:r>
+              <a:rPr sz="1400">
+                <a:solidFill>
+                  <a:srgbClr val="5B6575"/>
+                </a:solidFill>
+              </a:rPr>
+              <a:t>ims DNN 經 UPF 到 P-CSCF；不做 NAT，PCF 靠 UE IP 綁定 session</a:t>
+            </a:r>
+          </a:p>
+        </p:txBody>
+      </p:sp>
+      <p:sp>
+        <p:nvSpPr>
+          <p:cNvPr id="9" name="Shape 9">
+            <a:extLst>
+              <a:ext uri="{FF2B5EF4-FFF2-40B4-BE49-F238E27FC236}">
+                <a16:creationId xmlns:a16="http://schemas.microsoft.com/office/drawing/2014/main" id="{BA94A52B-2473-43C8-9CA8-EF2D4730432B}"/>
+              </a:ext>
+            </a:extLst>
+          </p:cNvPr>
+          <p:cNvSpPr/>
+          <p:nvPr/>
+        </p:nvSpPr>
+        <p:spPr>
+          <a:xfrm>
+            <a:off x="4476750" y="1543050"/>
+            <a:ext cx="7048500" cy="9525"/>
+          </a:xfrm>
+          <a:prstGeom prst="rect">
+            <a:avLst/>
+          </a:prstGeom>
+          <a:solidFill>
+            <a:srgbClr val="D5DAE1"/>
+          </a:solidFill>
+        </p:spPr>
+        <p:txBody>
+          <a:bodyPr wrap="square" rtlCol="0"/>
+          <a:lstStyle/>
+          <a:p>
+            <a:r>
+              <a:rPr/>
+              <a:t/>
+            </a:r>
+          </a:p>
+        </p:txBody>
+      </p:sp>
+      <p:sp>
+        <p:nvSpPr>
+          <p:cNvPr id="10" name="Shape 10">
+            <a:extLst>
+              <a:ext uri="{FF2B5EF4-FFF2-40B4-BE49-F238E27FC236}">
+                <a16:creationId xmlns:a16="http://schemas.microsoft.com/office/drawing/2014/main" id="{773ECFB9-CF12-492D-A3A3-60473036A2A4}"/>
+              </a:ext>
+            </a:extLst>
+          </p:cNvPr>
+          <p:cNvSpPr/>
+          <p:nvPr/>
+        </p:nvSpPr>
+        <p:spPr>
+          <a:xfrm>
+            <a:off x="4476750" y="1676400"/>
+            <a:ext cx="1047750" cy="457200"/>
+          </a:xfrm>
+          <a:prstGeom prst="roundRect">
+            <a:avLst/>
+          </a:prstGeom>
+          <a:solidFill>
+            <a:srgbClr val="0F4C81"/>
+          </a:solidFill>
+        </p:spPr>
+        <p:txBody>
+          <a:bodyPr wrap="square" rtlCol="0" lIns="0" tIns="0" rIns="0" bIns="0" anchor="ctr"/>
+          <a:lstStyle/>
+          <a:p>
+            <a:pPr algn="ctr"/>
+            <a:r>
+              <a:rPr sz="1800" b="1">
+                <a:solidFill>
+                  <a:srgbClr val="FFFFFF"/>
+                </a:solidFill>
+              </a:rPr>
+              <a:t>DNN</a:t>
+            </a:r>
+          </a:p>
+        </p:txBody>
+      </p:sp>
+      <p:sp>
+        <p:nvSpPr>
+          <p:cNvPr id="11" name="TextBox 11">
+            <a:extLst>
+              <a:ext uri="{FF2B5EF4-FFF2-40B4-BE49-F238E27FC236}">
+                <a16:creationId xmlns:a16="http://schemas.microsoft.com/office/drawing/2014/main" id="{5AEE5952-0E9F-41E2-8FA0-13549C03F719}"/>
+              </a:ext>
+            </a:extLst>
+          </p:cNvPr>
+          <p:cNvSpPr txBox="1"/>
+          <p:nvPr/>
+        </p:nvSpPr>
+        <p:spPr>
+          <a:xfrm>
+            <a:off x="5762625" y="1676400"/>
+            <a:ext cx="5810250" cy="952500"/>
+          </a:xfrm>
+        </p:spPr>
+        <p:txBody>
+          <a:bodyPr wrap="square" rtlCol="0" lIns="0" tIns="0" rIns="0" bIns="0" anchor="t">
+            <a:spAutoFit/>
+          </a:bodyPr>
+          <a:lstStyle/>
+          <a:p>
+            <a:pPr>
+              <a:spcAft>
+                <a:spcPts val="400"/>
+              </a:spcAft>
+            </a:pPr>
+            <a:r>
+              <a:rPr sz="1700" b="1">
+                <a:solidFill>
+                  <a:srgbClr val="14213D"/>
+                </a:solidFill>
+              </a:rPr>
+              <a:t>ims DNN 與預設 QoS</a:t>
+            </a:r>
+          </a:p>
+          <a:p>
+            <a:r>
+              <a:rPr sz="1400">
+                <a:solidFill>
+                  <a:srgbClr val="5B6575"/>
+                </a:solidFill>
+              </a:rPr>
+              <a:t>位址池 10.62/16，預設 5QI 5（IMS 信令）</a:t>
+            </a:r>
+          </a:p>
+        </p:txBody>
+      </p:sp>
+      <p:sp>
+        <p:nvSpPr>
+          <p:cNvPr id="12" name="Shape 12">
+            <a:extLst>
+              <a:ext uri="{FF2B5EF4-FFF2-40B4-BE49-F238E27FC236}">
+                <a16:creationId xmlns:a16="http://schemas.microsoft.com/office/drawing/2014/main" id="{1C34FFB8-5C56-4EA6-8D19-1B5996305A63}"/>
+              </a:ext>
+            </a:extLst>
+          </p:cNvPr>
+          <p:cNvSpPr/>
+          <p:nvPr/>
+        </p:nvSpPr>
+        <p:spPr>
+          <a:xfrm>
+            <a:off x="4476750" y="2762250"/>
+            <a:ext cx="7048500" cy="9525"/>
+          </a:xfrm>
+          <a:prstGeom prst="rect">
+            <a:avLst/>
+          </a:prstGeom>
+          <a:solidFill>
+            <a:srgbClr val="D5DAE1"/>
+          </a:solidFill>
+        </p:spPr>
+        <p:txBody>
+          <a:bodyPr wrap="square" rtlCol="0"/>
+          <a:lstStyle/>
+          <a:p>
+            <a:r>
+              <a:rPr/>
+              <a:t/>
+            </a:r>
+          </a:p>
+        </p:txBody>
+      </p:sp>
+      <p:sp>
+        <p:nvSpPr>
+          <p:cNvPr id="13" name="Shape 13">
+            <a:extLst>
+              <a:ext uri="{FF2B5EF4-FFF2-40B4-BE49-F238E27FC236}">
+                <a16:creationId xmlns:a16="http://schemas.microsoft.com/office/drawing/2014/main" id="{446B3160-0829-46AA-9509-78E8D95AC509}"/>
+              </a:ext>
+            </a:extLst>
+          </p:cNvPr>
+          <p:cNvSpPr/>
+          <p:nvPr/>
+        </p:nvSpPr>
+        <p:spPr>
+          <a:xfrm>
+            <a:off x="4476750" y="2895600"/>
+            <a:ext cx="1047750" cy="457200"/>
+          </a:xfrm>
+          <a:prstGeom prst="roundRect">
+            <a:avLst/>
+          </a:prstGeom>
+          <a:solidFill>
+            <a:srgbClr val="E8742A"/>
+          </a:solidFill>
+        </p:spPr>
+        <p:txBody>
+          <a:bodyPr wrap="square" rtlCol="0" lIns="0" tIns="0" rIns="0" bIns="0" anchor="ctr"/>
+          <a:lstStyle/>
+          <a:p>
+            <a:pPr algn="ctr"/>
+            <a:r>
+              <a:rPr sz="1800" b="1">
+                <a:solidFill>
+                  <a:srgbClr val="FFFFFF"/>
+                </a:solidFill>
+              </a:rPr>
+              <a:t>PCO</a:t>
+            </a:r>
+          </a:p>
+        </p:txBody>
+      </p:sp>
+      <p:sp>
+        <p:nvSpPr>
+          <p:cNvPr id="14" name="TextBox 14">
+            <a:extLst>
+              <a:ext uri="{FF2B5EF4-FFF2-40B4-BE49-F238E27FC236}">
+                <a16:creationId xmlns:a16="http://schemas.microsoft.com/office/drawing/2014/main" id="{E1DDA938-13D5-4176-9D07-F04173806B12}"/>
+              </a:ext>
+            </a:extLst>
+          </p:cNvPr>
+          <p:cNvSpPr txBox="1"/>
+          <p:nvPr/>
+        </p:nvSpPr>
+        <p:spPr>
+          <a:xfrm>
+            <a:off x="5762625" y="2895600"/>
+            <a:ext cx="5810250" cy="952500"/>
+          </a:xfrm>
+        </p:spPr>
+        <p:txBody>
+          <a:bodyPr wrap="square" rtlCol="0" lIns="0" tIns="0" rIns="0" bIns="0" anchor="t">
+            <a:spAutoFit/>
+          </a:bodyPr>
+          <a:lstStyle/>
+          <a:p>
+            <a:pPr>
+              <a:spcAft>
+                <a:spcPts val="400"/>
+              </a:spcAft>
+            </a:pPr>
+            <a:r>
+              <a:rPr sz="1700" b="1">
+                <a:solidFill>
+                  <a:srgbClr val="14213D"/>
+                </a:solidFill>
+              </a:rPr>
+              <a:t>探索：SMF 告訴 UE「P-CSCF 在哪」</a:t>
+            </a:r>
+          </a:p>
+          <a:p>
+            <a:r>
+              <a:rPr sz="1400">
+                <a:solidFill>
+                  <a:srgbClr val="5B6575"/>
+                </a:solidFill>
+              </a:rPr>
+              <a:t>UE 建 PDU session 時要求，SMF 在 Accept 回傳</a:t>
+            </a:r>
+          </a:p>
+        </p:txBody>
+      </p:sp>
+      <p:sp>
+        <p:nvSpPr>
+          <p:cNvPr id="15" name="Shape 15">
+            <a:extLst>
+              <a:ext uri="{FF2B5EF4-FFF2-40B4-BE49-F238E27FC236}">
+                <a16:creationId xmlns:a16="http://schemas.microsoft.com/office/drawing/2014/main" id="{242B61C9-7925-449B-A224-A86DC28BAE15}"/>
+              </a:ext>
+            </a:extLst>
+          </p:cNvPr>
+          <p:cNvSpPr/>
+          <p:nvPr/>
+        </p:nvSpPr>
+        <p:spPr>
+          <a:xfrm>
+            <a:off x="4476750" y="3981450"/>
+            <a:ext cx="7048500" cy="9525"/>
+          </a:xfrm>
+          <a:prstGeom prst="rect">
+            <a:avLst/>
+          </a:prstGeom>
+          <a:solidFill>
+            <a:srgbClr val="D5DAE1"/>
+          </a:solidFill>
+        </p:spPr>
+        <p:txBody>
+          <a:bodyPr wrap="square" rtlCol="0"/>
+          <a:lstStyle/>
+          <a:p>
+            <a:r>
+              <a:rPr/>
+              <a:t/>
+            </a:r>
+          </a:p>
+        </p:txBody>
+      </p:sp>
+      <p:sp>
+        <p:nvSpPr>
+          <p:cNvPr id="16" name="Shape 16">
+            <a:extLst>
+              <a:ext uri="{FF2B5EF4-FFF2-40B4-BE49-F238E27FC236}">
+                <a16:creationId xmlns:a16="http://schemas.microsoft.com/office/drawing/2014/main" id="{93B899B3-A81F-474D-80C6-86851FB81D02}"/>
+              </a:ext>
+            </a:extLst>
+          </p:cNvPr>
+          <p:cNvSpPr/>
+          <p:nvPr/>
+        </p:nvSpPr>
+        <p:spPr>
+          <a:xfrm>
+            <a:off x="4476750" y="4114800"/>
+            <a:ext cx="1047750" cy="457200"/>
+          </a:xfrm>
+          <a:prstGeom prst="roundRect">
+            <a:avLst/>
+          </a:prstGeom>
+          <a:solidFill>
+            <a:srgbClr val="0F4C81"/>
+          </a:solidFill>
+        </p:spPr>
+        <p:txBody>
+          <a:bodyPr wrap="square" rtlCol="0" lIns="0" tIns="0" rIns="0" bIns="0" anchor="ctr"/>
+          <a:lstStyle/>
+          <a:p>
+            <a:pPr algn="ctr"/>
+            <a:r>
+              <a:rPr sz="1800" b="1">
+                <a:solidFill>
+                  <a:srgbClr val="FFFFFF"/>
+                </a:solidFill>
+              </a:rPr>
+              <a:t>身分</a:t>
+            </a:r>
+          </a:p>
+        </p:txBody>
+      </p:sp>
+      <p:sp>
+        <p:nvSpPr>
+          <p:cNvPr id="17" name="TextBox 17">
+            <a:extLst>
+              <a:ext uri="{FF2B5EF4-FFF2-40B4-BE49-F238E27FC236}">
+                <a16:creationId xmlns:a16="http://schemas.microsoft.com/office/drawing/2014/main" id="{D03AF5B7-05DD-4248-A7F6-6328D1B89FD1}"/>
+              </a:ext>
+            </a:extLst>
+          </p:cNvPr>
+          <p:cNvSpPr txBox="1"/>
+          <p:nvPr/>
+        </p:nvSpPr>
+        <p:spPr>
+          <a:xfrm>
+            <a:off x="5762625" y="4114800"/>
+            <a:ext cx="5810250" cy="952500"/>
+          </a:xfrm>
+        </p:spPr>
+        <p:txBody>
+          <a:bodyPr wrap="square" rtlCol="0" lIns="0" tIns="0" rIns="0" bIns="0" anchor="t">
+            <a:spAutoFit/>
+          </a:bodyPr>
+          <a:lstStyle/>
+          <a:p>
+            <a:pPr>
+              <a:spcAft>
+                <a:spcPts val="400"/>
+              </a:spcAft>
+            </a:pPr>
+            <a:r>
+              <a:rPr sz="1700" b="1">
+                <a:solidFill>
+                  <a:srgbClr val="14213D"/>
+                </a:solidFill>
+              </a:rPr>
+              <a:t>用戶身分與金鑰</a:t>
+            </a:r>
+          </a:p>
+          <a:p>
+            <a:r>
+              <a:rPr sz="1400">
+                <a:solidFill>
+                  <a:srgbClr val="5B6575"/>
+                </a:solidFill>
+              </a:rPr>
+              <a:t>UDR 與 PyHSS 各存一份，從同一個 IMSI、同一個 OP 推導</a:t>
+            </a:r>
+          </a:p>
+        </p:txBody>
+      </p:sp>
+      <p:sp>
+        <p:nvSpPr>
+          <p:cNvPr id="18" name="Shape 18">
+            <a:extLst>
+              <a:ext uri="{FF2B5EF4-FFF2-40B4-BE49-F238E27FC236}">
+                <a16:creationId xmlns:a16="http://schemas.microsoft.com/office/drawing/2014/main" id="{A945B221-D7C8-4F5C-900C-80EDEFC590AE}"/>
+              </a:ext>
+            </a:extLst>
+          </p:cNvPr>
+          <p:cNvSpPr/>
+          <p:nvPr/>
+        </p:nvSpPr>
+        <p:spPr>
+          <a:xfrm>
+            <a:off x="4476750" y="5200650"/>
+            <a:ext cx="7048500" cy="9525"/>
+          </a:xfrm>
+          <a:prstGeom prst="rect">
+            <a:avLst/>
+          </a:prstGeom>
+          <a:solidFill>
+            <a:srgbClr val="D5DAE1"/>
+          </a:solidFill>
+        </p:spPr>
+        <p:txBody>
+          <a:bodyPr wrap="square" rtlCol="0"/>
+          <a:lstStyle/>
+          <a:p>
+            <a:r>
+              <a:rPr/>
+              <a:t/>
+            </a:r>
+          </a:p>
+        </p:txBody>
+      </p:sp>
+      <p:sp>
+        <p:nvSpPr>
+          <p:cNvPr id="19" name="Shape 19">
+            <a:extLst>
+              <a:ext uri="{FF2B5EF4-FFF2-40B4-BE49-F238E27FC236}">
+                <a16:creationId xmlns:a16="http://schemas.microsoft.com/office/drawing/2014/main" id="{836492F7-444F-455E-81E0-20FAC2B35BD7}"/>
+              </a:ext>
+            </a:extLst>
+          </p:cNvPr>
+          <p:cNvSpPr/>
+          <p:nvPr/>
+        </p:nvSpPr>
+        <p:spPr>
+          <a:xfrm>
+            <a:off x="4476750" y="5334000"/>
+            <a:ext cx="1047750" cy="457200"/>
+          </a:xfrm>
+          <a:prstGeom prst="roundRect">
+            <a:avLst/>
+          </a:prstGeom>
+          <a:solidFill>
+            <a:srgbClr val="E8742A"/>
+          </a:solidFill>
+        </p:spPr>
+        <p:txBody>
+          <a:bodyPr wrap="square" rtlCol="0" lIns="0" tIns="0" rIns="0" bIns="0" anchor="ctr"/>
+          <a:lstStyle/>
+          <a:p>
+            <a:pPr algn="ctr"/>
+            <a:r>
+              <a:rPr sz="1800" b="1">
+                <a:solidFill>
+                  <a:srgbClr val="FFFFFF"/>
+                </a:solidFill>
+              </a:rPr>
+              <a:t>N5</a:t>
+            </a:r>
+          </a:p>
+        </p:txBody>
+      </p:sp>
+      <p:sp>
+        <p:nvSpPr>
+          <p:cNvPr id="20" name="TextBox 20">
+            <a:extLst>
+              <a:ext uri="{FF2B5EF4-FFF2-40B4-BE49-F238E27FC236}">
+                <a16:creationId xmlns:a16="http://schemas.microsoft.com/office/drawing/2014/main" id="{F0DE9C02-B962-4E4E-8A92-088207A5515C}"/>
+              </a:ext>
+            </a:extLst>
+          </p:cNvPr>
+          <p:cNvSpPr txBox="1"/>
+          <p:nvPr/>
+        </p:nvSpPr>
+        <p:spPr>
+          <a:xfrm>
+            <a:off x="5762625" y="5334000"/>
+            <a:ext cx="5810250" cy="952500"/>
+          </a:xfrm>
+        </p:spPr>
+        <p:txBody>
+          <a:bodyPr wrap="square" rtlCol="0" lIns="0" tIns="0" rIns="0" bIns="0" anchor="t">
+            <a:spAutoFit/>
+          </a:bodyPr>
+          <a:lstStyle/>
+          <a:p>
+            <a:pPr>
+              <a:spcAft>
+                <a:spcPts val="400"/>
+              </a:spcAft>
+            </a:pPr>
+            <a:r>
+              <a:rPr sz="1700" b="1">
+                <a:solidFill>
+                  <a:srgbClr val="14213D"/>
+                </a:solidFill>
+              </a:rPr>
+              <a:t>控制面：P-CSCF 以 AF 身分向 PCF 要 QoS</a:t>
+            </a:r>
+          </a:p>
+          <a:p>
+            <a:r>
+              <a:rPr sz="1400">
+                <a:solidFill>
+                  <a:srgbClr val="5B6575"/>
+                </a:solidFill>
+              </a:rPr>
+              <a:t>語音 flow 從 5QI 5 升到 5QI 1（GBR）</a:t>
+            </a:r>
+          </a:p>
+        </p:txBody>
+      </p:sp>
+    </p:spTree>
+  </p:cSld>
+  <p:clrMapOvr>
+    <a:masterClrMapping/>
+  </p:clrMapOvr>
+</p:sld>
+</file>
+
 <file path=ppt/slides/slide3.xml><?xml version="1.0" encoding="utf-8"?>
 <p:sld xmlns:a="http://schemas.openxmlformats.org/drawingml/2006/main" xmlns:r="http://schemas.openxmlformats.org/officeDocument/2006/relationships" xmlns:p="http://schemas.openxmlformats.org/presentationml/2006/main">
   <p:cSld>
@@ -19440,6 +19451,732 @@
                 </a:solidFill>
               </a:rPr>
               <a:t>   5GC 是公路，IMS 是電話公司的總機</a:t>
+            </a:r>
+          </a:p>
+        </p:txBody>
+      </p:sp>
+    </p:spTree>
+  </p:cSld>
+  <p:clrMapOvr>
+    <a:masterClrMapping/>
+  </p:clrMapOvr>
+</p:sld>
+</file>
+
+<file path=ppt/slides/slide30.xml><?xml version="1.0" encoding="utf-8"?>
+<p:sld xmlns:a="http://schemas.openxmlformats.org/drawingml/2006/main" xmlns:r="http://schemas.openxmlformats.org/officeDocument/2006/relationships" xmlns:p="http://schemas.openxmlformats.org/presentationml/2006/main">
+  <p:cSld>
+    <p:bg>
+      <p:bgPr>
+        <a:solidFill>
+          <a:srgbClr val="F6F7F9"/>
+        </a:solidFill>
+        <a:effectLst/>
+      </p:bgPr>
+    </p:bg>
+    <p:spTree>
+      <p:nvGrpSpPr>
+        <p:cNvPr id="1" name=""/>
+        <p:cNvGrpSpPr/>
+        <p:nvPr/>
+      </p:nvGrpSpPr>
+      <p:grpSpPr>
+        <a:xfrm>
+          <a:off x="0" y="0"/>
+          <a:ext cx="0" cy="0"/>
+          <a:chOff x="0" y="0"/>
+          <a:chExt cx="0" cy="0"/>
+        </a:xfrm>
+      </p:grpSpPr>
+      <p:sp>
+        <p:nvSpPr>
+          <p:cNvPr id="3" name="Shape 3">
+            <a:extLst>
+              <a:ext uri="{FF2B5EF4-FFF2-40B4-BE49-F238E27FC236}">
+                <a16:creationId xmlns:a16="http://schemas.microsoft.com/office/drawing/2014/main" id="{FEAC1951-A1DF-45D2-AA34-62C7AF5DBD66}"/>
+              </a:ext>
+            </a:extLst>
+          </p:cNvPr>
+          <p:cNvSpPr/>
+          <p:nvPr/>
+        </p:nvSpPr>
+        <p:spPr>
+          <a:xfrm>
+            <a:off x="666750" y="1524000"/>
+            <a:ext cx="1981200" cy="3657600"/>
+          </a:xfrm>
+          <a:prstGeom prst="roundRect">
+            <a:avLst/>
+          </a:prstGeom>
+          <a:solidFill>
+            <a:srgbClr val="FFFFFF"/>
+          </a:solidFill>
+          <a:ln w="12700">
+            <a:solidFill>
+              <a:srgbClr val="D5DAE1"/>
+            </a:solidFill>
+          </a:ln>
+        </p:spPr>
+        <p:txBody>
+          <a:bodyPr wrap="square" rtlCol="0"/>
+          <a:lstStyle/>
+          <a:p>
+            <a:r>
+              <a:rPr/>
+              <a:t/>
+            </a:r>
+          </a:p>
+        </p:txBody>
+      </p:sp>
+      <p:sp>
+        <p:nvSpPr>
+          <p:cNvPr id="4" name="Shape 4">
+            <a:extLst>
+              <a:ext uri="{FF2B5EF4-FFF2-40B4-BE49-F238E27FC236}">
+                <a16:creationId xmlns:a16="http://schemas.microsoft.com/office/drawing/2014/main" id="{9630AF76-2775-457A-9E0E-0CB44E25D03D}"/>
+              </a:ext>
+            </a:extLst>
+          </p:cNvPr>
+          <p:cNvSpPr/>
+          <p:nvPr/>
+        </p:nvSpPr>
+        <p:spPr>
+          <a:xfrm>
+            <a:off x="2886075" y="1524000"/>
+            <a:ext cx="1981200" cy="3657600"/>
+          </a:xfrm>
+          <a:prstGeom prst="roundRect">
+            <a:avLst/>
+          </a:prstGeom>
+          <a:solidFill>
+            <a:srgbClr val="FFFFFF"/>
+          </a:solidFill>
+          <a:ln w="12700">
+            <a:solidFill>
+              <a:srgbClr val="D5DAE1"/>
+            </a:solidFill>
+          </a:ln>
+        </p:spPr>
+        <p:txBody>
+          <a:bodyPr wrap="square" rtlCol="0"/>
+          <a:lstStyle/>
+          <a:p>
+            <a:r>
+              <a:rPr/>
+              <a:t/>
+            </a:r>
+          </a:p>
+        </p:txBody>
+      </p:sp>
+      <p:sp>
+        <p:nvSpPr>
+          <p:cNvPr id="5" name="Shape 5">
+            <a:extLst>
+              <a:ext uri="{FF2B5EF4-FFF2-40B4-BE49-F238E27FC236}">
+                <a16:creationId xmlns:a16="http://schemas.microsoft.com/office/drawing/2014/main" id="{5AA32294-C048-46E9-8B34-C403E4EF4728}"/>
+              </a:ext>
+            </a:extLst>
+          </p:cNvPr>
+          <p:cNvSpPr/>
+          <p:nvPr/>
+        </p:nvSpPr>
+        <p:spPr>
+          <a:xfrm>
+            <a:off x="5105400" y="1524000"/>
+            <a:ext cx="1981200" cy="3657600"/>
+          </a:xfrm>
+          <a:prstGeom prst="roundRect">
+            <a:avLst/>
+          </a:prstGeom>
+          <a:solidFill>
+            <a:srgbClr val="FCEBDD"/>
+          </a:solidFill>
+        </p:spPr>
+        <p:txBody>
+          <a:bodyPr wrap="square" rtlCol="0"/>
+          <a:lstStyle/>
+          <a:p>
+            <a:r>
+              <a:rPr/>
+              <a:t/>
+            </a:r>
+          </a:p>
+        </p:txBody>
+      </p:sp>
+      <p:sp>
+        <p:nvSpPr>
+          <p:cNvPr id="6" name="Shape 6">
+            <a:extLst>
+              <a:ext uri="{FF2B5EF4-FFF2-40B4-BE49-F238E27FC236}">
+                <a16:creationId xmlns:a16="http://schemas.microsoft.com/office/drawing/2014/main" id="{D2C686B3-C7E6-41B1-80CE-6853E0226A94}"/>
+              </a:ext>
+            </a:extLst>
+          </p:cNvPr>
+          <p:cNvSpPr/>
+          <p:nvPr/>
+        </p:nvSpPr>
+        <p:spPr>
+          <a:xfrm>
+            <a:off x="7324725" y="1524000"/>
+            <a:ext cx="1981200" cy="3657600"/>
+          </a:xfrm>
+          <a:prstGeom prst="roundRect">
+            <a:avLst/>
+          </a:prstGeom>
+          <a:solidFill>
+            <a:srgbClr val="FFFFFF"/>
+          </a:solidFill>
+          <a:ln w="12700">
+            <a:solidFill>
+              <a:srgbClr val="D5DAE1"/>
+            </a:solidFill>
+          </a:ln>
+        </p:spPr>
+        <p:txBody>
+          <a:bodyPr wrap="square" rtlCol="0"/>
+          <a:lstStyle/>
+          <a:p>
+            <a:r>
+              <a:rPr/>
+              <a:t/>
+            </a:r>
+          </a:p>
+        </p:txBody>
+      </p:sp>
+      <p:sp>
+        <p:nvSpPr>
+          <p:cNvPr id="7" name="Shape 7">
+            <a:extLst>
+              <a:ext uri="{FF2B5EF4-FFF2-40B4-BE49-F238E27FC236}">
+                <a16:creationId xmlns:a16="http://schemas.microsoft.com/office/drawing/2014/main" id="{A2DEF08C-335B-4479-8892-69EE78C904EE}"/>
+              </a:ext>
+            </a:extLst>
+          </p:cNvPr>
+          <p:cNvSpPr/>
+          <p:nvPr/>
+        </p:nvSpPr>
+        <p:spPr>
+          <a:xfrm>
+            <a:off x="9544050" y="1524000"/>
+            <a:ext cx="1981200" cy="3657600"/>
+          </a:xfrm>
+          <a:prstGeom prst="roundRect">
+            <a:avLst/>
+          </a:prstGeom>
+          <a:solidFill>
+            <a:srgbClr val="FFFFFF"/>
+          </a:solidFill>
+          <a:ln w="12700">
+            <a:solidFill>
+              <a:srgbClr val="D5DAE1"/>
+            </a:solidFill>
+          </a:ln>
+        </p:spPr>
+        <p:txBody>
+          <a:bodyPr wrap="square" rtlCol="0"/>
+          <a:lstStyle/>
+          <a:p>
+            <a:r>
+              <a:rPr/>
+              <a:t/>
+            </a:r>
+          </a:p>
+        </p:txBody>
+      </p:sp>
+      <p:sp>
+        <p:nvSpPr>
+          <p:cNvPr id="8" name="TextBox 8">
+            <a:extLst>
+              <a:ext uri="{FF2B5EF4-FFF2-40B4-BE49-F238E27FC236}">
+                <a16:creationId xmlns:a16="http://schemas.microsoft.com/office/drawing/2014/main" id="{5715AACF-30BE-45EE-802A-CC991C7CC10D}"/>
+              </a:ext>
+            </a:extLst>
+          </p:cNvPr>
+          <p:cNvSpPr txBox="1"/>
+          <p:nvPr/>
+        </p:nvSpPr>
+        <p:spPr>
+          <a:xfrm>
+            <a:off x="666750" y="533400"/>
+            <a:ext cx="10858500" cy="609600"/>
+          </a:xfrm>
+        </p:spPr>
+        <p:txBody>
+          <a:bodyPr wrap="square" rtlCol="0" lIns="0" tIns="0" rIns="0" bIns="0" anchor="t">
+            <a:spAutoFit/>
+          </a:bodyPr>
+          <a:lstStyle/>
+          <a:p>
+            <a:r>
+              <a:rPr sz="3600" b="1">
+                <a:solidFill>
+                  <a:srgbClr val="14213D"/>
+                </a:solidFill>
+              </a:rPr>
+              <a:t>現行 AF shim 的五個問題</a:t>
+            </a:r>
+          </a:p>
+        </p:txBody>
+      </p:sp>
+      <p:sp>
+        <p:nvSpPr>
+          <p:cNvPr id="9" name="TextBox 9">
+            <a:extLst>
+              <a:ext uri="{FF2B5EF4-FFF2-40B4-BE49-F238E27FC236}">
+                <a16:creationId xmlns:a16="http://schemas.microsoft.com/office/drawing/2014/main" id="{EF1A65BC-11C7-4E79-B10A-1C8980CA63F2}"/>
+              </a:ext>
+            </a:extLst>
+          </p:cNvPr>
+          <p:cNvSpPr txBox="1"/>
+          <p:nvPr/>
+        </p:nvSpPr>
+        <p:spPr>
+          <a:xfrm>
+            <a:off x="819150" y="1714500"/>
+            <a:ext cx="1676400" cy="3333750"/>
+          </a:xfrm>
+        </p:spPr>
+        <p:txBody>
+          <a:bodyPr wrap="square" rtlCol="0" lIns="0" tIns="0" rIns="0" bIns="0" anchor="t">
+            <a:spAutoFit/>
+          </a:bodyPr>
+          <a:lstStyle/>
+          <a:p>
+            <a:pPr>
+              <a:spcAft>
+                <a:spcPts val="600"/>
+              </a:spcAft>
+            </a:pPr>
+            <a:r>
+              <a:rPr sz="4000" b="1">
+                <a:solidFill>
+                  <a:srgbClr val="E8742A"/>
+                </a:solidFill>
+              </a:rPr>
+              <a:t>01</a:t>
+            </a:r>
+          </a:p>
+          <a:p>
+            <a:pPr>
+              <a:spcAft>
+                <a:spcPts val="1200"/>
+              </a:spcAft>
+            </a:pPr>
+            <a:r>
+              <a:rPr sz="1800" b="1">
+                <a:solidFill>
+                  <a:srgbClr val="14213D"/>
+                </a:solidFill>
+              </a:rPr>
+              <a:t>自訂 JSON 介面</a:t>
+            </a:r>
+          </a:p>
+          <a:p>
+            <a:pPr>
+              <a:lnSpc>
+                <a:spcPct val="125000"/>
+              </a:lnSpc>
+              <a:spcAft>
+                <a:spcPts val="2000"/>
+              </a:spcAft>
+            </a:pPr>
+            <a:r>
+              <a:rPr sz="1800">
+                <a:solidFill>
+                  <a:srgbClr val="5B6575"/>
+                </a:solidFill>
+              </a:rPr>
+              <a:t>換掉任一端都要重寫</a:t>
+            </a:r>
+          </a:p>
+          <a:p>
+            <a:r>
+              <a:rPr sz="1500">
+                <a:solidFill>
+                  <a:srgbClr val="0F4C81"/>
+                </a:solidFill>
+              </a:rPr>
+              <a:t>route[AF_RESERVE]</a:t>
+            </a:r>
+          </a:p>
+        </p:txBody>
+      </p:sp>
+      <p:sp>
+        <p:nvSpPr>
+          <p:cNvPr id="10" name="TextBox 10">
+            <a:extLst>
+              <a:ext uri="{FF2B5EF4-FFF2-40B4-BE49-F238E27FC236}">
+                <a16:creationId xmlns:a16="http://schemas.microsoft.com/office/drawing/2014/main" id="{9E3E353F-8948-4BEB-9755-A0103312B0DC}"/>
+              </a:ext>
+            </a:extLst>
+          </p:cNvPr>
+          <p:cNvSpPr txBox="1"/>
+          <p:nvPr/>
+        </p:nvSpPr>
+        <p:spPr>
+          <a:xfrm>
+            <a:off x="3038475" y="1714500"/>
+            <a:ext cx="1676400" cy="3333750"/>
+          </a:xfrm>
+        </p:spPr>
+        <p:txBody>
+          <a:bodyPr wrap="square" rtlCol="0" lIns="0" tIns="0" rIns="0" bIns="0" anchor="t">
+            <a:spAutoFit/>
+          </a:bodyPr>
+          <a:lstStyle/>
+          <a:p>
+            <a:pPr>
+              <a:spcAft>
+                <a:spcPts val="600"/>
+              </a:spcAft>
+            </a:pPr>
+            <a:r>
+              <a:rPr sz="4000" b="1">
+                <a:solidFill>
+                  <a:srgbClr val="E8742A"/>
+                </a:solidFill>
+              </a:rPr>
+              <a:t>02</a:t>
+            </a:r>
+          </a:p>
+          <a:p>
+            <a:pPr>
+              <a:spcAft>
+                <a:spcPts val="1200"/>
+              </a:spcAft>
+            </a:pPr>
+            <a:r>
+              <a:rPr sz="1800" b="1">
+                <a:solidFill>
+                  <a:srgbClr val="14213D"/>
+                </a:solidFill>
+              </a:rPr>
+              <a:t>AF 邏輯散在 cfg</a:t>
+            </a:r>
+          </a:p>
+          <a:p>
+            <a:pPr>
+              <a:lnSpc>
+                <a:spcPct val="125000"/>
+              </a:lnSpc>
+              <a:spcAft>
+                <a:spcPts val="2000"/>
+              </a:spcAft>
+            </a:pPr>
+            <a:r>
+              <a:rPr sz="1800">
+                <a:solidFill>
+                  <a:srgbClr val="5B6575"/>
+                </a:solidFill>
+              </a:rPr>
+              <a:t>寫在 SIP 路由腳本，難測試</a:t>
+            </a:r>
+          </a:p>
+          <a:p>
+            <a:r>
+              <a:rPr sz="1500">
+                <a:solidFill>
+                  <a:srgbClr val="0F4C81"/>
+                </a:solidFill>
+              </a:rPr>
+              <a:t>AF_KEY / AF_RELEASE</a:t>
+            </a:r>
+          </a:p>
+        </p:txBody>
+      </p:sp>
+      <p:sp>
+        <p:nvSpPr>
+          <p:cNvPr id="11" name="TextBox 11">
+            <a:extLst>
+              <a:ext uri="{FF2B5EF4-FFF2-40B4-BE49-F238E27FC236}">
+                <a16:creationId xmlns:a16="http://schemas.microsoft.com/office/drawing/2014/main" id="{BB696475-FF0E-4A72-A825-AFC980CED85F}"/>
+              </a:ext>
+            </a:extLst>
+          </p:cNvPr>
+          <p:cNvSpPr txBox="1"/>
+          <p:nvPr/>
+        </p:nvSpPr>
+        <p:spPr>
+          <a:xfrm>
+            <a:off x="5257800" y="1714500"/>
+            <a:ext cx="1676400" cy="3333750"/>
+          </a:xfrm>
+        </p:spPr>
+        <p:txBody>
+          <a:bodyPr wrap="square" rtlCol="0" lIns="0" tIns="0" rIns="0" bIns="0" anchor="t">
+            <a:spAutoFit/>
+          </a:bodyPr>
+          <a:lstStyle/>
+          <a:p>
+            <a:pPr>
+              <a:spcAft>
+                <a:spcPts val="600"/>
+              </a:spcAft>
+            </a:pPr>
+            <a:r>
+              <a:rPr sz="4000" b="1">
+                <a:solidFill>
+                  <a:srgbClr val="E8742A"/>
+                </a:solidFill>
+              </a:rPr>
+              <a:t>03</a:t>
+            </a:r>
+          </a:p>
+          <a:p>
+            <a:pPr>
+              <a:spcAft>
+                <a:spcPts val="1200"/>
+              </a:spcAft>
+            </a:pPr>
+            <a:r>
+              <a:rPr sz="1800" b="1">
+                <a:solidFill>
+                  <a:srgbClr val="14213D"/>
+                </a:solidFill>
+              </a:rPr>
+              <a:t>PCF 通知收不到</a:t>
+            </a:r>
+          </a:p>
+          <a:p>
+            <a:pPr>
+              <a:lnSpc>
+                <a:spcPct val="125000"/>
+              </a:lnSpc>
+              <a:spcAft>
+                <a:spcPts val="2000"/>
+              </a:spcAft>
+            </a:pPr>
+            <a:r>
+              <a:rPr sz="1800">
+                <a:solidFill>
+                  <a:srgbClr val="5B6575"/>
+                </a:solidFill>
+              </a:rPr>
+              <a:t>終止通知送到 /notify/terminate，shim 回 404</a:t>
+            </a:r>
+          </a:p>
+          <a:p>
+            <a:r>
+              <a:rPr sz="1500">
+                <a:solidFill>
+                  <a:srgbClr val="0F4C81"/>
+                </a:solidFill>
+              </a:rPr>
+              <a:t>只接 /notify</a:t>
+            </a:r>
+          </a:p>
+        </p:txBody>
+      </p:sp>
+      <p:sp>
+        <p:nvSpPr>
+          <p:cNvPr id="12" name="TextBox 12">
+            <a:extLst>
+              <a:ext uri="{FF2B5EF4-FFF2-40B4-BE49-F238E27FC236}">
+                <a16:creationId xmlns:a16="http://schemas.microsoft.com/office/drawing/2014/main" id="{D1FED307-57CC-45EC-A89B-4C77AB2FABB8}"/>
+              </a:ext>
+            </a:extLst>
+          </p:cNvPr>
+          <p:cNvSpPr txBox="1"/>
+          <p:nvPr/>
+        </p:nvSpPr>
+        <p:spPr>
+          <a:xfrm>
+            <a:off x="7477125" y="1714500"/>
+            <a:ext cx="1676400" cy="3333750"/>
+          </a:xfrm>
+        </p:spPr>
+        <p:txBody>
+          <a:bodyPr wrap="square" rtlCol="0" lIns="0" tIns="0" rIns="0" bIns="0" anchor="t">
+            <a:spAutoFit/>
+          </a:bodyPr>
+          <a:lstStyle/>
+          <a:p>
+            <a:pPr>
+              <a:spcAft>
+                <a:spcPts val="600"/>
+              </a:spcAft>
+            </a:pPr>
+            <a:r>
+              <a:rPr sz="4000" b="1">
+                <a:solidFill>
+                  <a:srgbClr val="E8742A"/>
+                </a:solidFill>
+              </a:rPr>
+              <a:t>04</a:t>
+            </a:r>
+          </a:p>
+          <a:p>
+            <a:pPr>
+              <a:spcAft>
+                <a:spcPts val="1200"/>
+              </a:spcAft>
+            </a:pPr>
+            <a:r>
+              <a:rPr sz="1800" b="1">
+                <a:solidFill>
+                  <a:srgbClr val="14213D"/>
+                </a:solidFill>
+              </a:rPr>
+              <a:t>同步 HTTP 呼叫</a:t>
+            </a:r>
+          </a:p>
+          <a:p>
+            <a:pPr>
+              <a:lnSpc>
+                <a:spcPct val="125000"/>
+              </a:lnSpc>
+              <a:spcAft>
+                <a:spcPts val="2000"/>
+              </a:spcAft>
+            </a:pPr>
+            <a:r>
+              <a:rPr sz="1800">
+                <a:solidFill>
+                  <a:srgbClr val="5B6575"/>
+                </a:solidFill>
+              </a:rPr>
+              <a:t>PCF 慢就卡住 worker</a:t>
+            </a:r>
+          </a:p>
+          <a:p>
+            <a:r>
+              <a:rPr sz="1500">
+                <a:solidFill>
+                  <a:srgbClr val="0F4C81"/>
+                </a:solidFill>
+              </a:rPr>
+              <a:t>http_client_query</a:t>
+            </a:r>
+          </a:p>
+        </p:txBody>
+      </p:sp>
+      <p:sp>
+        <p:nvSpPr>
+          <p:cNvPr id="13" name="TextBox 13">
+            <a:extLst>
+              <a:ext uri="{FF2B5EF4-FFF2-40B4-BE49-F238E27FC236}">
+                <a16:creationId xmlns:a16="http://schemas.microsoft.com/office/drawing/2014/main" id="{8B977662-C840-44C9-87B3-F6EA2BBAF8E7}"/>
+              </a:ext>
+            </a:extLst>
+          </p:cNvPr>
+          <p:cNvSpPr txBox="1"/>
+          <p:nvPr/>
+        </p:nvSpPr>
+        <p:spPr>
+          <a:xfrm>
+            <a:off x="9696450" y="1714500"/>
+            <a:ext cx="1676400" cy="3333750"/>
+          </a:xfrm>
+        </p:spPr>
+        <p:txBody>
+          <a:bodyPr wrap="square" rtlCol="0" lIns="0" tIns="0" rIns="0" bIns="0" anchor="t">
+            <a:spAutoFit/>
+          </a:bodyPr>
+          <a:lstStyle/>
+          <a:p>
+            <a:pPr>
+              <a:spcAft>
+                <a:spcPts val="600"/>
+              </a:spcAft>
+            </a:pPr>
+            <a:r>
+              <a:rPr sz="4000" b="1">
+                <a:solidFill>
+                  <a:srgbClr val="E8742A"/>
+                </a:solidFill>
+              </a:rPr>
+              <a:t>05</a:t>
+            </a:r>
+          </a:p>
+          <a:p>
+            <a:pPr>
+              <a:spcAft>
+                <a:spcPts val="1200"/>
+              </a:spcAft>
+            </a:pPr>
+            <a:r>
+              <a:rPr sz="1800" b="1">
+                <a:solidFill>
+                  <a:srgbClr val="14213D"/>
+                </a:solidFill>
+              </a:rPr>
+              <a:t>信令沒有 QoS</a:t>
+            </a:r>
+          </a:p>
+          <a:p>
+            <a:pPr>
+              <a:lnSpc>
+                <a:spcPct val="125000"/>
+              </a:lnSpc>
+              <a:spcAft>
+                <a:spcPts val="2000"/>
+              </a:spcAft>
+            </a:pPr>
+            <a:r>
+              <a:rPr sz="1800">
+                <a:solidFill>
+                  <a:srgbClr val="5B6575"/>
+                </a:solidFill>
+              </a:rPr>
+              <a:t>只預留媒體，信令沒有</a:t>
+            </a:r>
+          </a:p>
+          <a:p>
+            <a:r>
+              <a:rPr sz="1500">
+                <a:solidFill>
+                  <a:srgbClr val="0F4C81"/>
+                </a:solidFill>
+              </a:rPr>
+              <a:t>TS 24.229 / 29.214</a:t>
+            </a:r>
+          </a:p>
+        </p:txBody>
+      </p:sp>
+      <p:sp>
+        <p:nvSpPr>
+          <p:cNvPr id="14" name="Shape 14">
+            <a:extLst>
+              <a:ext uri="{FF2B5EF4-FFF2-40B4-BE49-F238E27FC236}">
+                <a16:creationId xmlns:a16="http://schemas.microsoft.com/office/drawing/2014/main" id="{1F9693C3-9A65-41BA-BDA7-5E690BB5E44B}"/>
+              </a:ext>
+            </a:extLst>
+          </p:cNvPr>
+          <p:cNvSpPr/>
+          <p:nvPr/>
+        </p:nvSpPr>
+        <p:spPr>
+          <a:xfrm>
+            <a:off x="666750" y="5448300"/>
+            <a:ext cx="10858500" cy="800100"/>
+          </a:xfrm>
+          <a:prstGeom prst="roundRect">
+            <a:avLst/>
+          </a:prstGeom>
+          <a:solidFill>
+            <a:srgbClr val="0B1B2E"/>
+          </a:solidFill>
+        </p:spPr>
+        <p:txBody>
+          <a:bodyPr wrap="square" rtlCol="0" lIns="0" tIns="0" rIns="0" bIns="0" anchor="ctr"/>
+          <a:lstStyle/>
+          <a:p>
+            <a:pPr algn="ctr"/>
+            <a:r>
+              <a:rPr sz="1700" b="1">
+                <a:solidFill>
+                  <a:srgbClr val="E8742A"/>
+                </a:solidFill>
+              </a:rPr>
+              <a:t>根本原因：</a:t>
+            </a:r>
+            <a:r>
+              <a:rPr sz="1700">
+                <a:solidFill>
+                  <a:srgbClr val="FFFFFF"/>
+                </a:solidFill>
+              </a:rPr>
+              <a:t>AF 邏輯拆在 cfg 與 shim，兩邊都不是標準介面</a:t>
             </a:r>
           </a:p>
         </p:txBody>

</xml_diff>